<commit_message>
Add literature folder, schematic PDFs, update PPTX schematics
</commit_message>
<xml_diff>
--- a/prototyping/E_dzPAR_schematic.pptx
+++ b/prototyping/E_dzPAR_schematic.pptx
@@ -4,13 +4,13 @@
   <p:sldMasterIdLst>
     <p:sldMasterId id="2147483648" r:id="rId1"/>
   </p:sldMasterIdLst>
+  <p:notesMasterIdLst>
+    <p:notesMasterId r:id="rId4"/>
+  </p:notesMasterIdLst>
   <p:sldIdLst>
     <p:sldId id="256" r:id="rId2"/>
     <p:sldId id="257" r:id="rId3"/>
   </p:sldIdLst>
-  <p:notesMasterIdLst>
-    <p:notesMasterId r:id="rId4"/>
-  </p:notesMasterIdLst>
   <p:sldSz cx="12192000" cy="6858000"/>
   <p:notesSz cx="6858000" cy="12192000"/>
   <p:defaultTextStyle>
@@ -105,6 +105,11 @@
       </a:defRPr>
     </a:lvl9pPr>
   </p:defaultTextStyle>
+  <p:extLst>
+    <p:ext uri="{EFAFB233-063F-42B5-8137-9DF3F51BA10A}">
+      <p15:sldGuideLst xmlns:p15="http://schemas.microsoft.com/office/powerpoint/2012/main"/>
+    </p:ext>
+  </p:extLst>
 </p:presentation>
 </file>
 
@@ -130,234 +135,10 @@
           <a:chExt cx="0" cy="0"/>
         </a:xfrm>
       </p:grpSpPr>
-      <p:sp>
-        <p:nvSpPr>
-          <p:cNvPr id="2" name="Header Placeholder 1"/>
-          <p:cNvSpPr>
-            <a:spLocks noGrp="1"/>
-          </p:cNvSpPr>
-          <p:nvPr>
-            <p:ph type="hdr" sz="quarter"/>
-          </p:nvPr>
-        </p:nvSpPr>
-        <p:spPr>
-          <a:xfrm>
-            <a:off x="0" y="0"/>
-            <a:ext cx="2971800" cy="458788"/>
-          </a:xfrm>
-          <a:prstGeom prst="rect">
-            <a:avLst/>
-          </a:prstGeom>
-        </p:spPr>
-        <p:txBody>
-          <a:bodyPr vert="horz" lIns="91440" tIns="45720" rIns="91440" bIns="45720" rtlCol="0"/>
-          <a:lstStyle>
-            <a:lvl1pPr algn="l">
-              <a:defRPr sz="1200"/>
-            </a:lvl1pPr>
-          </a:lstStyle>
-          <a:p>
-            <a:endParaRPr lang="en-US"/>
-          </a:p>
-        </p:txBody>
-      </p:sp>
-      <p:sp>
-        <p:nvSpPr>
-          <p:cNvPr id="3" name="Date Placeholder 2"/>
-          <p:cNvSpPr>
-            <a:spLocks noGrp="1"/>
-          </p:cNvSpPr>
-          <p:nvPr>
-            <p:ph type="dt" idx="1"/>
-          </p:nvPr>
-        </p:nvSpPr>
-        <p:spPr>
-          <a:xfrm>
-            <a:off x="3884613" y="0"/>
-            <a:ext cx="2971800" cy="458788"/>
-          </a:xfrm>
-          <a:prstGeom prst="rect">
-            <a:avLst/>
-          </a:prstGeom>
-        </p:spPr>
-        <p:txBody>
-          <a:bodyPr vert="horz" lIns="91440" tIns="45720" rIns="91440" bIns="45720" rtlCol="0"/>
-          <a:lstStyle>
-            <a:lvl1pPr algn="r">
-              <a:defRPr sz="1200"/>
-            </a:lvl1pPr>
-          </a:lstStyle>
-          <a:p>
-            <a:fld id="{5282F153-3F37-0F45-9E97-73ACFA13230C}" type="datetimeFigureOut">
-              <a:rPr lang="en-US"/>
-              <a:t>7/23/19</a:t>
-            </a:fld>
-            <a:endParaRPr lang="en-US"/>
-          </a:p>
-        </p:txBody>
-      </p:sp>
-      <p:sp>
-        <p:nvSpPr>
-          <p:cNvPr id="4" name="Slide Image Placeholder 3"/>
-          <p:cNvSpPr>
-            <a:spLocks noGrp="1" noRot="1" noChangeAspect="1"/>
-          </p:cNvSpPr>
-          <p:nvPr>
-            <p:ph type="sldImg" idx="2"/>
-          </p:nvPr>
-        </p:nvSpPr>
-        <p:spPr>
-          <a:xfrm>
-            <a:off x="685800" y="1143000"/>
-            <a:ext cx="5486400" cy="3086100"/>
-          </a:xfrm>
-          <a:prstGeom prst="rect">
-            <a:avLst/>
-          </a:prstGeom>
-          <a:noFill/>
-          <a:ln w="12700">
-            <a:solidFill>
-              <a:prstClr val="black"/>
-            </a:solidFill>
-          </a:ln>
-        </p:spPr>
-        <p:txBody>
-          <a:bodyPr vert="horz" lIns="91440" tIns="45720" rIns="91440" bIns="45720" rtlCol="0" anchor="ctr"/>
-          <a:lstStyle/>
-          <a:p>
-            <a:endParaRPr lang="en-US"/>
-          </a:p>
-        </p:txBody>
-      </p:sp>
-      <p:sp>
-        <p:nvSpPr>
-          <p:cNvPr id="5" name="Notes Placeholder 4"/>
-          <p:cNvSpPr>
-            <a:spLocks noGrp="1"/>
-          </p:cNvSpPr>
-          <p:nvPr>
-            <p:ph type="body" sz="quarter" idx="3"/>
-          </p:nvPr>
-        </p:nvSpPr>
-        <p:spPr>
-          <a:xfrm>
-            <a:off x="685800" y="4400550"/>
-            <a:ext cx="5486400" cy="3600450"/>
-          </a:xfrm>
-          <a:prstGeom prst="rect">
-            <a:avLst/>
-          </a:prstGeom>
-        </p:spPr>
-        <p:txBody>
-          <a:bodyPr vert="horz" lIns="91440" tIns="45720" rIns="91440" bIns="45720" rtlCol="0"/>
-          <a:lstStyle/>
-          <a:p>
-            <a:pPr lvl="0"/>
-            <a:r>
-              <a:rPr lang="en-US"/>
-              <a:t>Click to edit Master text styles</a:t>
-            </a:r>
-          </a:p>
-          <a:p>
-            <a:pPr lvl="1"/>
-            <a:r>
-              <a:rPr lang="en-US"/>
-              <a:t>Second level</a:t>
-            </a:r>
-          </a:p>
-          <a:p>
-            <a:pPr lvl="2"/>
-            <a:r>
-              <a:rPr lang="en-US"/>
-              <a:t>Third level</a:t>
-            </a:r>
-          </a:p>
-          <a:p>
-            <a:pPr lvl="3"/>
-            <a:r>
-              <a:rPr lang="en-US"/>
-              <a:t>Fourth level</a:t>
-            </a:r>
-          </a:p>
-          <a:p>
-            <a:pPr lvl="4"/>
-            <a:r>
-              <a:rPr lang="en-US"/>
-              <a:t>Fifth level</a:t>
-            </a:r>
-          </a:p>
-        </p:txBody>
-      </p:sp>
-      <p:sp>
-        <p:nvSpPr>
-          <p:cNvPr id="6" name="Footer Placeholder 5"/>
-          <p:cNvSpPr>
-            <a:spLocks noGrp="1"/>
-          </p:cNvSpPr>
-          <p:nvPr>
-            <p:ph type="ftr" sz="quarter" idx="4"/>
-          </p:nvPr>
-        </p:nvSpPr>
-        <p:spPr>
-          <a:xfrm>
-            <a:off x="0" y="8685213"/>
-            <a:ext cx="2971800" cy="458787"/>
-          </a:xfrm>
-          <a:prstGeom prst="rect">
-            <a:avLst/>
-          </a:prstGeom>
-        </p:spPr>
-        <p:txBody>
-          <a:bodyPr vert="horz" lIns="91440" tIns="45720" rIns="91440" bIns="45720" rtlCol="0" anchor="b"/>
-          <a:lstStyle>
-            <a:lvl1pPr algn="l">
-              <a:defRPr sz="1200"/>
-            </a:lvl1pPr>
-          </a:lstStyle>
-          <a:p>
-            <a:endParaRPr lang="en-US"/>
-          </a:p>
-        </p:txBody>
-      </p:sp>
-      <p:sp>
-        <p:nvSpPr>
-          <p:cNvPr id="7" name="Slide Number Placeholder 6"/>
-          <p:cNvSpPr>
-            <a:spLocks noGrp="1"/>
-          </p:cNvSpPr>
-          <p:nvPr>
-            <p:ph type="sldNum" sz="quarter" idx="5"/>
-          </p:nvPr>
-        </p:nvSpPr>
-        <p:spPr>
-          <a:xfrm>
-            <a:off x="3884613" y="8685213"/>
-            <a:ext cx="2971800" cy="458787"/>
-          </a:xfrm>
-          <a:prstGeom prst="rect">
-            <a:avLst/>
-          </a:prstGeom>
-        </p:spPr>
-        <p:txBody>
-          <a:bodyPr vert="horz" lIns="91440" tIns="45720" rIns="91440" bIns="45720" rtlCol="0" anchor="b"/>
-          <a:lstStyle>
-            <a:lvl1pPr algn="r">
-              <a:defRPr sz="1200"/>
-            </a:lvl1pPr>
-          </a:lstStyle>
-          <a:p>
-            <a:fld id="{CE5E9CC1-C706-0F49-92D6-E571CC5EEA8F}" type="slidenum">
-              <a:rPr lang="en-US"/>
-              <a:t>‹#›</a:t>
-            </a:fld>
-            <a:endParaRPr lang="en-US"/>
-          </a:p>
-        </p:txBody>
-      </p:sp>
     </p:spTree>
     <p:extLst>
       <p:ext uri="{BB962C8B-B14F-4D97-AF65-F5344CB8AC3E}">
-        <p14:creationId xmlns:p14="http://schemas.microsoft.com/office/powerpoint/2010/main" val="1024086991"/>
+        <p14:creationId xmlns:p14="http://schemas.microsoft.com/office/powerpoint/2010/main" val="3115041506"/>
       </p:ext>
     </p:extLst>
   </p:cSld>
@@ -501,10 +282,6 @@
           <a:bodyPr/>
           <a:lstStyle/>
           <a:p>
-            <a:r>
-              <a:rPr lang="en-US" dirty="0"/>
-              <a:t/>
-            </a:r>
             <a:endParaRPr lang="en-US" dirty="0"/>
           </a:p>
         </p:txBody>
@@ -589,10 +366,6 @@
           <a:bodyPr/>
           <a:lstStyle/>
           <a:p>
-            <a:r>
-              <a:rPr lang="en-US" dirty="0"/>
-              <a:t/>
-            </a:r>
             <a:endParaRPr lang="en-US" dirty="0"/>
           </a:p>
         </p:txBody>
@@ -666,6 +439,11 @@
 <file path=ppt/slideMasters/slideMaster1.xml><?xml version="1.0" encoding="utf-8"?>
 <p:sldMaster xmlns:a="http://schemas.openxmlformats.org/drawingml/2006/main" xmlns:r="http://schemas.openxmlformats.org/officeDocument/2006/relationships" xmlns:p="http://schemas.openxmlformats.org/presentationml/2006/main">
   <p:cSld>
+    <p:bg>
+      <p:bgRef idx="1001">
+        <a:schemeClr val="bg1"/>
+      </p:bgRef>
+    </p:bg>
     <p:spTree>
       <p:nvGrpSpPr>
         <p:cNvPr id="1" name=""/>
@@ -948,6 +726,7 @@
         <a:solidFill>
           <a:srgbClr val="FFFFFF"/>
         </a:solidFill>
+        <a:effectLst/>
       </p:bgPr>
     </p:bg>
     <p:spTree>
@@ -985,7 +764,7 @@
           <a:bodyPr wrap="square" lIns="0" tIns="0" rIns="0" bIns="0" rtlCol="0" anchor="ctr"/>
           <a:lstStyle/>
           <a:p>
-            <a:pPr indent="0" marL="0">
+            <a:pPr marL="0" indent="0">
               <a:buNone/>
             </a:pPr>
             <a:r>
@@ -997,21 +776,7 @@
                 <a:ea typeface="Calibri" pitchFamily="34" charset="-122"/>
                 <a:cs typeface="Calibri" pitchFamily="34" charset="-120"/>
               </a:rPr>
-              <a:t>PARcast</a:t>
-            </a:r>
-            <a:pPr indent="0" marL="0">
-              <a:buNone/>
-            </a:pPr>
-            <a:r>
-              <a:rPr lang="en-US" sz="2200" b="1" dirty="0">
-                <a:solidFill>
-                  <a:srgbClr val="1F2A44"/>
-                </a:solidFill>
-                <a:latin typeface="Calibri" pitchFamily="34" charset="0"/>
-                <a:ea typeface="Calibri" pitchFamily="34" charset="-122"/>
-                <a:cs typeface="Calibri" pitchFamily="34" charset="-120"/>
-              </a:rPr>
-              <a:t>: E_d(z, PAR) breadboard wiring</a:t>
+              <a:t>PARcast: E_d(z, PAR) breadboard wiring</a:t>
             </a:r>
             <a:endParaRPr lang="en-US" sz="2200" dirty="0"/>
           </a:p>
@@ -1038,7 +803,7 @@
           <a:bodyPr wrap="square" lIns="0" tIns="0" rIns="0" bIns="0" rtlCol="0" anchor="ctr"/>
           <a:lstStyle/>
           <a:p>
-            <a:pPr indent="0" marL="0">
+            <a:pPr marL="0" indent="0">
               <a:buNone/>
             </a:pPr>
             <a:r>
@@ -1082,6 +847,13 @@
             <a:prstDash val="solid"/>
           </a:ln>
         </p:spPr>
+        <p:txBody>
+          <a:bodyPr/>
+          <a:lstStyle/>
+          <a:p>
+            <a:endParaRPr lang="en-US"/>
+          </a:p>
+        </p:txBody>
       </p:sp>
       <p:sp>
         <p:nvSpPr>
@@ -1105,6 +877,13 @@
             <a:prstDash val="solid"/>
           </a:ln>
         </p:spPr>
+        <p:txBody>
+          <a:bodyPr/>
+          <a:lstStyle/>
+          <a:p>
+            <a:endParaRPr lang="en-US"/>
+          </a:p>
+        </p:txBody>
       </p:sp>
       <p:sp>
         <p:nvSpPr>
@@ -1128,6 +907,13 @@
             <a:prstDash val="solid"/>
           </a:ln>
         </p:spPr>
+        <p:txBody>
+          <a:bodyPr/>
+          <a:lstStyle/>
+          <a:p>
+            <a:endParaRPr lang="en-US"/>
+          </a:p>
+        </p:txBody>
       </p:sp>
       <p:sp>
         <p:nvSpPr>
@@ -1151,6 +937,13 @@
             <a:prstDash val="solid"/>
           </a:ln>
         </p:spPr>
+        <p:txBody>
+          <a:bodyPr/>
+          <a:lstStyle/>
+          <a:p>
+            <a:endParaRPr lang="en-US"/>
+          </a:p>
+        </p:txBody>
       </p:sp>
       <p:sp>
         <p:nvSpPr>
@@ -1174,6 +967,13 @@
             <a:prstDash val="solid"/>
           </a:ln>
         </p:spPr>
+        <p:txBody>
+          <a:bodyPr/>
+          <a:lstStyle/>
+          <a:p>
+            <a:endParaRPr lang="en-US"/>
+          </a:p>
+        </p:txBody>
       </p:sp>
       <p:sp>
         <p:nvSpPr>
@@ -1196,7 +996,7 @@
           <a:bodyPr wrap="square" lIns="0" tIns="0" rIns="0" bIns="0" rtlCol="0" anchor="ctr"/>
           <a:lstStyle/>
           <a:p>
-            <a:pPr algn="ctr" indent="0" marL="0">
+            <a:pPr marL="0" indent="0" algn="ctr">
               <a:buNone/>
             </a:pPr>
             <a:r>
@@ -1232,7 +1032,7 @@
           <a:bodyPr wrap="square" lIns="0" tIns="0" rIns="0" bIns="0" rtlCol="0" anchor="ctr"/>
           <a:lstStyle/>
           <a:p>
-            <a:pPr algn="ctr" indent="0" marL="0">
+            <a:pPr marL="0" indent="0" algn="ctr">
               <a:buNone/>
             </a:pPr>
             <a:r>
@@ -1268,7 +1068,7 @@
           <a:bodyPr wrap="square" lIns="0" tIns="0" rIns="0" bIns="0" rtlCol="0" anchor="ctr"/>
           <a:lstStyle/>
           <a:p>
-            <a:pPr algn="ctr" indent="0" marL="0">
+            <a:pPr marL="0" indent="0" algn="ctr">
               <a:buNone/>
             </a:pPr>
             <a:r>
@@ -1304,7 +1104,7 @@
           <a:bodyPr wrap="square" lIns="0" tIns="0" rIns="0" bIns="0" rtlCol="0" anchor="ctr"/>
           <a:lstStyle/>
           <a:p>
-            <a:pPr algn="ctr" indent="0" marL="0">
+            <a:pPr marL="0" indent="0" algn="ctr">
               <a:buNone/>
             </a:pPr>
             <a:r>
@@ -1340,7 +1140,7 @@
           <a:bodyPr wrap="square" lIns="0" tIns="0" rIns="0" bIns="0" rtlCol="0" anchor="ctr"/>
           <a:lstStyle/>
           <a:p>
-            <a:pPr algn="ctr" indent="0" marL="0">
+            <a:pPr marL="0" indent="0" algn="ctr">
               <a:buNone/>
             </a:pPr>
             <a:r>
@@ -1376,7 +1176,7 @@
           <a:bodyPr wrap="square" lIns="0" tIns="0" rIns="0" bIns="0" rtlCol="0" anchor="ctr"/>
           <a:lstStyle/>
           <a:p>
-            <a:pPr algn="ctr" indent="0" marL="0">
+            <a:pPr marL="0" indent="0" algn="ctr">
               <a:buNone/>
             </a:pPr>
             <a:r>
@@ -1412,7 +1212,7 @@
           <a:bodyPr wrap="square" lIns="0" tIns="0" rIns="0" bIns="0" rtlCol="0" anchor="ctr"/>
           <a:lstStyle/>
           <a:p>
-            <a:pPr algn="ctr" indent="0" marL="0">
+            <a:pPr marL="0" indent="0" algn="ctr">
               <a:buNone/>
             </a:pPr>
             <a:r>
@@ -1448,7 +1248,7 @@
           <a:bodyPr wrap="square" lIns="0" tIns="0" rIns="0" bIns="0" rtlCol="0" anchor="ctr"/>
           <a:lstStyle/>
           <a:p>
-            <a:pPr algn="ctr" indent="0" marL="0">
+            <a:pPr marL="0" indent="0" algn="ctr">
               <a:buNone/>
             </a:pPr>
             <a:r>
@@ -1484,7 +1284,7 @@
           <a:bodyPr wrap="square" lIns="0" tIns="0" rIns="0" bIns="0" rtlCol="0" anchor="ctr"/>
           <a:lstStyle/>
           <a:p>
-            <a:pPr algn="ctr" indent="0" marL="0">
+            <a:pPr marL="0" indent="0" algn="ctr">
               <a:buNone/>
             </a:pPr>
             <a:r>
@@ -1520,7 +1320,7 @@
           <a:bodyPr wrap="square" lIns="0" tIns="0" rIns="0" bIns="0" rtlCol="0" anchor="ctr"/>
           <a:lstStyle/>
           <a:p>
-            <a:pPr algn="ctr" indent="0" marL="0">
+            <a:pPr marL="0" indent="0" algn="ctr">
               <a:buNone/>
             </a:pPr>
             <a:r>
@@ -1556,7 +1356,7 @@
           <a:bodyPr wrap="square" lIns="0" tIns="0" rIns="0" bIns="0" rtlCol="0" anchor="ctr"/>
           <a:lstStyle/>
           <a:p>
-            <a:pPr algn="ctr" indent="0" marL="0">
+            <a:pPr marL="0" indent="0" algn="ctr">
               <a:buNone/>
             </a:pPr>
             <a:r>
@@ -1592,7 +1392,7 @@
           <a:bodyPr wrap="square" lIns="0" tIns="0" rIns="0" bIns="0" rtlCol="0" anchor="ctr"/>
           <a:lstStyle/>
           <a:p>
-            <a:pPr algn="ctr" indent="0" marL="0">
+            <a:pPr marL="0" indent="0" algn="ctr">
               <a:buNone/>
             </a:pPr>
             <a:r>
@@ -1628,7 +1428,7 @@
           <a:bodyPr wrap="square" lIns="0" tIns="0" rIns="0" bIns="0" rtlCol="0" anchor="ctr"/>
           <a:lstStyle/>
           <a:p>
-            <a:pPr algn="ctr" indent="0" marL="0">
+            <a:pPr marL="0" indent="0" algn="ctr">
               <a:buNone/>
             </a:pPr>
             <a:r>
@@ -1664,7 +1464,7 @@
           <a:bodyPr wrap="square" lIns="0" tIns="0" rIns="0" bIns="0" rtlCol="0" anchor="ctr"/>
           <a:lstStyle/>
           <a:p>
-            <a:pPr algn="ctr" indent="0" marL="0">
+            <a:pPr marL="0" indent="0" algn="ctr">
               <a:buNone/>
             </a:pPr>
             <a:r>
@@ -1700,7 +1500,7 @@
           <a:bodyPr wrap="square" lIns="0" tIns="0" rIns="0" bIns="0" rtlCol="0" anchor="ctr"/>
           <a:lstStyle/>
           <a:p>
-            <a:pPr algn="ctr" indent="0" marL="0">
+            <a:pPr marL="0" indent="0" algn="ctr">
               <a:buNone/>
             </a:pPr>
             <a:r>
@@ -1736,7 +1536,7 @@
           <a:bodyPr wrap="square" lIns="0" tIns="0" rIns="0" bIns="0" rtlCol="0" anchor="ctr"/>
           <a:lstStyle/>
           <a:p>
-            <a:pPr algn="ctr" indent="0" marL="0">
+            <a:pPr marL="0" indent="0" algn="ctr">
               <a:buNone/>
             </a:pPr>
             <a:r>
@@ -1772,7 +1572,7 @@
           <a:bodyPr wrap="square" lIns="0" tIns="0" rIns="0" bIns="0" rtlCol="0" anchor="ctr"/>
           <a:lstStyle/>
           <a:p>
-            <a:pPr algn="ctr" indent="0" marL="0">
+            <a:pPr marL="0" indent="0" algn="ctr">
               <a:buNone/>
             </a:pPr>
             <a:r>
@@ -1808,7 +1608,7 @@
           <a:bodyPr wrap="square" lIns="0" tIns="0" rIns="0" bIns="0" rtlCol="0" anchor="ctr"/>
           <a:lstStyle/>
           <a:p>
-            <a:pPr algn="ctr" indent="0" marL="0">
+            <a:pPr marL="0" indent="0" algn="ctr">
               <a:buNone/>
             </a:pPr>
             <a:r>
@@ -1844,7 +1644,7 @@
           <a:bodyPr wrap="square" lIns="0" tIns="0" rIns="0" bIns="0" rtlCol="0" anchor="ctr"/>
           <a:lstStyle/>
           <a:p>
-            <a:pPr algn="ctr" indent="0" marL="0">
+            <a:pPr marL="0" indent="0" algn="ctr">
               <a:buNone/>
             </a:pPr>
             <a:r>
@@ -1880,7 +1680,7 @@
           <a:bodyPr wrap="square" lIns="0" tIns="0" rIns="0" bIns="0" rtlCol="0" anchor="ctr"/>
           <a:lstStyle/>
           <a:p>
-            <a:pPr algn="ctr" indent="0" marL="0">
+            <a:pPr marL="0" indent="0" algn="ctr">
               <a:buNone/>
             </a:pPr>
             <a:r>
@@ -1916,7 +1716,7 @@
           <a:bodyPr wrap="square" lIns="0" tIns="0" rIns="0" bIns="0" rtlCol="0" anchor="ctr"/>
           <a:lstStyle/>
           <a:p>
-            <a:pPr algn="ctr" indent="0" marL="0">
+            <a:pPr marL="0" indent="0" algn="ctr">
               <a:buNone/>
             </a:pPr>
             <a:r>
@@ -1952,7 +1752,7 @@
           <a:bodyPr wrap="square" lIns="0" tIns="0" rIns="0" bIns="0" rtlCol="0" anchor="ctr"/>
           <a:lstStyle/>
           <a:p>
-            <a:pPr algn="ctr" indent="0" marL="0">
+            <a:pPr marL="0" indent="0" algn="ctr">
               <a:buNone/>
             </a:pPr>
             <a:r>
@@ -1988,7 +1788,7 @@
           <a:bodyPr wrap="square" lIns="0" tIns="0" rIns="0" bIns="0" rtlCol="0" anchor="ctr"/>
           <a:lstStyle/>
           <a:p>
-            <a:pPr algn="ctr" indent="0" marL="0">
+            <a:pPr marL="0" indent="0" algn="ctr">
               <a:buNone/>
             </a:pPr>
             <a:r>
@@ -2024,7 +1824,7 @@
           <a:bodyPr wrap="square" lIns="0" tIns="0" rIns="0" bIns="0" rtlCol="0" anchor="ctr"/>
           <a:lstStyle/>
           <a:p>
-            <a:pPr algn="ctr" indent="0" marL="0">
+            <a:pPr marL="0" indent="0" algn="ctr">
               <a:buNone/>
             </a:pPr>
             <a:r>
@@ -2060,7 +1860,7 @@
           <a:bodyPr wrap="square" lIns="0" tIns="0" rIns="0" bIns="0" rtlCol="0" anchor="ctr"/>
           <a:lstStyle/>
           <a:p>
-            <a:pPr algn="ctr" indent="0" marL="0">
+            <a:pPr marL="0" indent="0" algn="ctr">
               <a:buNone/>
             </a:pPr>
             <a:r>
@@ -2096,7 +1896,7 @@
           <a:bodyPr wrap="square" lIns="0" tIns="0" rIns="0" bIns="0" rtlCol="0" anchor="ctr"/>
           <a:lstStyle/>
           <a:p>
-            <a:pPr algn="ctr" indent="0" marL="0">
+            <a:pPr marL="0" indent="0" algn="ctr">
               <a:buNone/>
             </a:pPr>
             <a:r>
@@ -2132,7 +1932,7 @@
           <a:bodyPr wrap="square" lIns="0" tIns="0" rIns="0" bIns="0" rtlCol="0" anchor="ctr"/>
           <a:lstStyle/>
           <a:p>
-            <a:pPr algn="ctr" indent="0" marL="0">
+            <a:pPr marL="0" indent="0" algn="ctr">
               <a:buNone/>
             </a:pPr>
             <a:r>
@@ -2168,7 +1968,7 @@
           <a:bodyPr wrap="square" lIns="0" tIns="0" rIns="0" bIns="0" rtlCol="0" anchor="ctr"/>
           <a:lstStyle/>
           <a:p>
-            <a:pPr algn="ctr" indent="0" marL="0">
+            <a:pPr marL="0" indent="0" algn="ctr">
               <a:buNone/>
             </a:pPr>
             <a:r>
@@ -2204,7 +2004,7 @@
           <a:bodyPr wrap="square" lIns="0" tIns="0" rIns="0" bIns="0" rtlCol="0" anchor="ctr"/>
           <a:lstStyle/>
           <a:p>
-            <a:pPr algn="ctr" indent="0" marL="0">
+            <a:pPr marL="0" indent="0" algn="ctr">
               <a:buNone/>
             </a:pPr>
             <a:r>
@@ -2240,7 +2040,7 @@
           <a:bodyPr wrap="square" lIns="0" tIns="0" rIns="0" bIns="0" rtlCol="0" anchor="ctr"/>
           <a:lstStyle/>
           <a:p>
-            <a:pPr algn="ctr" indent="0" marL="0">
+            <a:pPr marL="0" indent="0" algn="ctr">
               <a:buNone/>
             </a:pPr>
             <a:r>
@@ -2276,7 +2076,7 @@
           <a:bodyPr wrap="square" lIns="0" tIns="0" rIns="0" bIns="0" rtlCol="0" anchor="ctr"/>
           <a:lstStyle/>
           <a:p>
-            <a:pPr algn="ctr" indent="0" marL="0">
+            <a:pPr marL="0" indent="0" algn="ctr">
               <a:buNone/>
             </a:pPr>
             <a:r>
@@ -2312,7 +2112,7 @@
           <a:bodyPr wrap="square" lIns="0" tIns="0" rIns="0" bIns="0" rtlCol="0" anchor="ctr"/>
           <a:lstStyle/>
           <a:p>
-            <a:pPr algn="ctr" indent="0" marL="0">
+            <a:pPr marL="0" indent="0" algn="ctr">
               <a:buNone/>
             </a:pPr>
             <a:r>
@@ -2348,7 +2148,7 @@
           <a:bodyPr wrap="square" lIns="0" tIns="0" rIns="0" bIns="0" rtlCol="0" anchor="ctr"/>
           <a:lstStyle/>
           <a:p>
-            <a:pPr algn="ctr" indent="0" marL="0">
+            <a:pPr marL="0" indent="0" algn="ctr">
               <a:buNone/>
             </a:pPr>
             <a:r>
@@ -2384,7 +2184,7 @@
           <a:bodyPr wrap="square" lIns="0" tIns="0" rIns="0" bIns="0" rtlCol="0" anchor="ctr"/>
           <a:lstStyle/>
           <a:p>
-            <a:pPr algn="ctr" indent="0" marL="0">
+            <a:pPr marL="0" indent="0" algn="ctr">
               <a:buNone/>
             </a:pPr>
             <a:r>
@@ -2420,7 +2220,7 @@
           <a:bodyPr wrap="square" lIns="0" tIns="0" rIns="0" bIns="0" rtlCol="0" anchor="ctr"/>
           <a:lstStyle/>
           <a:p>
-            <a:pPr algn="ctr" indent="0" marL="0">
+            <a:pPr marL="0" indent="0" algn="ctr">
               <a:buNone/>
             </a:pPr>
             <a:r>
@@ -2456,7 +2256,7 @@
           <a:bodyPr wrap="square" lIns="0" tIns="0" rIns="0" bIns="0" rtlCol="0" anchor="ctr"/>
           <a:lstStyle/>
           <a:p>
-            <a:pPr algn="ctr" indent="0" marL="0">
+            <a:pPr marL="0" indent="0" algn="ctr">
               <a:buNone/>
             </a:pPr>
             <a:r>
@@ -2492,7 +2292,7 @@
           <a:bodyPr wrap="square" lIns="0" tIns="0" rIns="0" bIns="0" rtlCol="0" anchor="ctr"/>
           <a:lstStyle/>
           <a:p>
-            <a:pPr algn="ctr" indent="0" marL="0">
+            <a:pPr marL="0" indent="0" algn="ctr">
               <a:buNone/>
             </a:pPr>
             <a:r>
@@ -2528,7 +2328,7 @@
           <a:bodyPr wrap="square" lIns="0" tIns="0" rIns="0" bIns="0" rtlCol="0" anchor="ctr"/>
           <a:lstStyle/>
           <a:p>
-            <a:pPr algn="ctr" indent="0" marL="0">
+            <a:pPr marL="0" indent="0" algn="ctr">
               <a:buNone/>
             </a:pPr>
             <a:r>
@@ -2564,7 +2364,7 @@
           <a:bodyPr wrap="square" lIns="0" tIns="0" rIns="0" bIns="0" rtlCol="0" anchor="ctr"/>
           <a:lstStyle/>
           <a:p>
-            <a:pPr algn="ctr" indent="0" marL="0">
+            <a:pPr marL="0" indent="0" algn="ctr">
               <a:buNone/>
             </a:pPr>
             <a:r>
@@ -2600,7 +2400,7 @@
           <a:bodyPr wrap="square" lIns="0" tIns="0" rIns="0" bIns="0" rtlCol="0" anchor="ctr"/>
           <a:lstStyle/>
           <a:p>
-            <a:pPr algn="ctr" indent="0" marL="0">
+            <a:pPr marL="0" indent="0" algn="ctr">
               <a:buNone/>
             </a:pPr>
             <a:r>
@@ -2636,7 +2436,7 @@
           <a:bodyPr wrap="square" lIns="0" tIns="0" rIns="0" bIns="0" rtlCol="0" anchor="ctr"/>
           <a:lstStyle/>
           <a:p>
-            <a:pPr algn="ctr" indent="0" marL="0">
+            <a:pPr marL="0" indent="0" algn="ctr">
               <a:buNone/>
             </a:pPr>
             <a:r>
@@ -2672,7 +2472,7 @@
           <a:bodyPr wrap="square" lIns="0" tIns="0" rIns="0" bIns="0" rtlCol="0" anchor="ctr"/>
           <a:lstStyle/>
           <a:p>
-            <a:pPr algn="ctr" indent="0" marL="0">
+            <a:pPr marL="0" indent="0" algn="ctr">
               <a:buNone/>
             </a:pPr>
             <a:r>
@@ -2708,7 +2508,7 @@
           <a:bodyPr wrap="square" lIns="0" tIns="0" rIns="0" bIns="0" rtlCol="0" anchor="ctr"/>
           <a:lstStyle/>
           <a:p>
-            <a:pPr algn="ctr" indent="0" marL="0">
+            <a:pPr marL="0" indent="0" algn="ctr">
               <a:buNone/>
             </a:pPr>
             <a:r>
@@ -2744,7 +2544,7 @@
           <a:bodyPr wrap="square" lIns="0" tIns="0" rIns="0" bIns="0" rtlCol="0" anchor="ctr"/>
           <a:lstStyle/>
           <a:p>
-            <a:pPr algn="ctr" indent="0" marL="0">
+            <a:pPr marL="0" indent="0" algn="ctr">
               <a:buNone/>
             </a:pPr>
             <a:r>
@@ -2780,7 +2580,7 @@
           <a:bodyPr wrap="square" lIns="0" tIns="0" rIns="0" bIns="0" rtlCol="0" anchor="ctr"/>
           <a:lstStyle/>
           <a:p>
-            <a:pPr algn="ctr" indent="0" marL="0">
+            <a:pPr marL="0" indent="0" algn="ctr">
               <a:buNone/>
             </a:pPr>
             <a:r>
@@ -2816,7 +2616,7 @@
           <a:bodyPr wrap="square" lIns="0" tIns="0" rIns="0" bIns="0" rtlCol="0" anchor="ctr"/>
           <a:lstStyle/>
           <a:p>
-            <a:pPr algn="ctr" indent="0" marL="0">
+            <a:pPr marL="0" indent="0" algn="ctr">
               <a:buNone/>
             </a:pPr>
             <a:r>
@@ -2852,7 +2652,7 @@
           <a:bodyPr wrap="square" lIns="0" tIns="0" rIns="0" bIns="0" rtlCol="0" anchor="ctr"/>
           <a:lstStyle/>
           <a:p>
-            <a:pPr algn="ctr" indent="0" marL="0">
+            <a:pPr marL="0" indent="0" algn="ctr">
               <a:buNone/>
             </a:pPr>
             <a:r>
@@ -2888,7 +2688,7 @@
           <a:bodyPr wrap="square" lIns="0" tIns="0" rIns="0" bIns="0" rtlCol="0" anchor="ctr"/>
           <a:lstStyle/>
           <a:p>
-            <a:pPr algn="ctr" indent="0" marL="0">
+            <a:pPr marL="0" indent="0" algn="ctr">
               <a:buNone/>
             </a:pPr>
             <a:r>
@@ -2924,7 +2724,7 @@
           <a:bodyPr wrap="square" lIns="0" tIns="0" rIns="0" bIns="0" rtlCol="0" anchor="ctr"/>
           <a:lstStyle/>
           <a:p>
-            <a:pPr algn="ctr" indent="0" marL="0">
+            <a:pPr marL="0" indent="0" algn="ctr">
               <a:buNone/>
             </a:pPr>
             <a:r>
@@ -2960,7 +2760,7 @@
           <a:bodyPr wrap="square" lIns="0" tIns="0" rIns="0" bIns="0" rtlCol="0" anchor="ctr"/>
           <a:lstStyle/>
           <a:p>
-            <a:pPr algn="ctr" indent="0" marL="0">
+            <a:pPr marL="0" indent="0" algn="ctr">
               <a:buNone/>
             </a:pPr>
             <a:r>
@@ -2996,7 +2796,7 @@
           <a:bodyPr wrap="square" lIns="0" tIns="0" rIns="0" bIns="0" rtlCol="0" anchor="ctr"/>
           <a:lstStyle/>
           <a:p>
-            <a:pPr algn="ctr" indent="0" marL="0">
+            <a:pPr marL="0" indent="0" algn="ctr">
               <a:buNone/>
             </a:pPr>
             <a:r>
@@ -3032,7 +2832,7 @@
           <a:bodyPr wrap="square" lIns="0" tIns="0" rIns="0" bIns="0" rtlCol="0" anchor="ctr"/>
           <a:lstStyle/>
           <a:p>
-            <a:pPr algn="ctr" indent="0" marL="0">
+            <a:pPr marL="0" indent="0" algn="ctr">
               <a:buNone/>
             </a:pPr>
             <a:r>
@@ -3073,6 +2873,13 @@
             <a:prstDash val="solid"/>
           </a:ln>
         </p:spPr>
+        <p:txBody>
+          <a:bodyPr/>
+          <a:lstStyle/>
+          <a:p>
+            <a:endParaRPr lang="en-US"/>
+          </a:p>
+        </p:txBody>
       </p:sp>
       <p:sp>
         <p:nvSpPr>
@@ -3095,7 +2902,7 @@
           <a:bodyPr wrap="square" lIns="0" tIns="0" rIns="0" bIns="0" rtlCol="0" anchor="ctr"/>
           <a:lstStyle/>
           <a:p>
-            <a:pPr algn="ctr" indent="0" marL="0">
+            <a:pPr marL="0" indent="0" algn="ctr">
               <a:buNone/>
             </a:pPr>
             <a:r>
@@ -3134,7 +2941,7 @@
           <a:bodyPr wrap="square" lIns="0" tIns="0" rIns="0" bIns="0" rtlCol="0" anchor="ctr"/>
           <a:lstStyle/>
           <a:p>
-            <a:pPr algn="ctr" indent="0" marL="0">
+            <a:pPr marL="0" indent="0" algn="ctr">
               <a:buNone/>
             </a:pPr>
             <a:r>
@@ -3176,6 +2983,13 @@
             <a:prstDash val="solid"/>
           </a:ln>
         </p:spPr>
+        <p:txBody>
+          <a:bodyPr/>
+          <a:lstStyle/>
+          <a:p>
+            <a:endParaRPr lang="en-US"/>
+          </a:p>
+        </p:txBody>
       </p:sp>
       <p:sp>
         <p:nvSpPr>
@@ -3198,7 +3012,7 @@
           <a:bodyPr wrap="square" lIns="0" tIns="0" rIns="0" bIns="0" rtlCol="0" anchor="t"/>
           <a:lstStyle/>
           <a:p>
-            <a:pPr algn="ctr" indent="0" marL="0">
+            <a:pPr marL="0" indent="0" algn="ctr">
               <a:buNone/>
             </a:pPr>
             <a:r>
@@ -3240,6 +3054,13 @@
             <a:prstDash val="solid"/>
           </a:ln>
         </p:spPr>
+        <p:txBody>
+          <a:bodyPr/>
+          <a:lstStyle/>
+          <a:p>
+            <a:endParaRPr lang="en-US"/>
+          </a:p>
+        </p:txBody>
       </p:sp>
       <p:sp>
         <p:nvSpPr>
@@ -3262,7 +3083,7 @@
           <a:bodyPr wrap="square" lIns="0" tIns="0" rIns="0" bIns="0" rtlCol="0" anchor="t"/>
           <a:lstStyle/>
           <a:p>
-            <a:pPr algn="ctr" indent="0" marL="0">
+            <a:pPr marL="0" indent="0" algn="ctr">
               <a:buNone/>
             </a:pPr>
             <a:r>
@@ -3304,6 +3125,13 @@
             <a:prstDash val="solid"/>
           </a:ln>
         </p:spPr>
+        <p:txBody>
+          <a:bodyPr/>
+          <a:lstStyle/>
+          <a:p>
+            <a:endParaRPr lang="en-US"/>
+          </a:p>
+        </p:txBody>
       </p:sp>
       <p:sp>
         <p:nvSpPr>
@@ -3326,7 +3154,7 @@
           <a:bodyPr wrap="square" lIns="0" tIns="0" rIns="0" bIns="0" rtlCol="0" anchor="t"/>
           <a:lstStyle/>
           <a:p>
-            <a:pPr algn="ctr" indent="0" marL="0">
+            <a:pPr marL="0" indent="0" algn="ctr">
               <a:buNone/>
             </a:pPr>
             <a:r>
@@ -3368,6 +3196,13 @@
             <a:prstDash val="solid"/>
           </a:ln>
         </p:spPr>
+        <p:txBody>
+          <a:bodyPr/>
+          <a:lstStyle/>
+          <a:p>
+            <a:endParaRPr lang="en-US"/>
+          </a:p>
+        </p:txBody>
       </p:sp>
       <p:sp>
         <p:nvSpPr>
@@ -3390,7 +3225,7 @@
           <a:bodyPr wrap="square" lIns="0" tIns="0" rIns="0" bIns="0" rtlCol="0" anchor="t"/>
           <a:lstStyle/>
           <a:p>
-            <a:pPr algn="ctr" indent="0" marL="0">
+            <a:pPr marL="0" indent="0" algn="ctr">
               <a:buNone/>
             </a:pPr>
             <a:r>
@@ -3432,6 +3267,13 @@
             <a:prstDash val="solid"/>
           </a:ln>
         </p:spPr>
+        <p:txBody>
+          <a:bodyPr/>
+          <a:lstStyle/>
+          <a:p>
+            <a:endParaRPr lang="en-US"/>
+          </a:p>
+        </p:txBody>
       </p:sp>
       <p:sp>
         <p:nvSpPr>
@@ -3454,7 +3296,7 @@
           <a:bodyPr wrap="square" lIns="0" tIns="0" rIns="0" bIns="0" rtlCol="0" anchor="t"/>
           <a:lstStyle/>
           <a:p>
-            <a:pPr algn="ctr" indent="0" marL="0">
+            <a:pPr marL="0" indent="0" algn="ctr">
               <a:buNone/>
             </a:pPr>
             <a:r>
@@ -3496,6 +3338,13 @@
             <a:prstDash val="solid"/>
           </a:ln>
         </p:spPr>
+        <p:txBody>
+          <a:bodyPr/>
+          <a:lstStyle/>
+          <a:p>
+            <a:endParaRPr lang="en-US"/>
+          </a:p>
+        </p:txBody>
       </p:sp>
       <p:sp>
         <p:nvSpPr>
@@ -3518,7 +3367,7 @@
           <a:bodyPr wrap="square" lIns="0" tIns="0" rIns="0" bIns="0" rtlCol="0" anchor="t"/>
           <a:lstStyle/>
           <a:p>
-            <a:pPr algn="ctr" indent="0" marL="0">
+            <a:pPr marL="0" indent="0" algn="ctr">
               <a:buNone/>
             </a:pPr>
             <a:r>
@@ -3560,6 +3409,13 @@
             <a:prstDash val="solid"/>
           </a:ln>
         </p:spPr>
+        <p:txBody>
+          <a:bodyPr/>
+          <a:lstStyle/>
+          <a:p>
+            <a:endParaRPr lang="en-US"/>
+          </a:p>
+        </p:txBody>
       </p:sp>
       <p:sp>
         <p:nvSpPr>
@@ -3582,7 +3438,7 @@
           <a:bodyPr wrap="square" lIns="0" tIns="0" rIns="0" bIns="0" rtlCol="0" anchor="t"/>
           <a:lstStyle/>
           <a:p>
-            <a:pPr algn="ctr" indent="0" marL="0">
+            <a:pPr marL="0" indent="0" algn="ctr">
               <a:buNone/>
             </a:pPr>
             <a:r>
@@ -3624,6 +3480,13 @@
             <a:prstDash val="solid"/>
           </a:ln>
         </p:spPr>
+        <p:txBody>
+          <a:bodyPr/>
+          <a:lstStyle/>
+          <a:p>
+            <a:endParaRPr lang="en-US"/>
+          </a:p>
+        </p:txBody>
       </p:sp>
       <p:sp>
         <p:nvSpPr>
@@ -3646,7 +3509,7 @@
           <a:bodyPr wrap="square" lIns="0" tIns="0" rIns="0" bIns="0" rtlCol="0" anchor="t"/>
           <a:lstStyle/>
           <a:p>
-            <a:pPr algn="ctr" indent="0" marL="0">
+            <a:pPr marL="0" indent="0" algn="ctr">
               <a:buNone/>
             </a:pPr>
             <a:r>
@@ -3688,6 +3551,13 @@
             <a:prstDash val="solid"/>
           </a:ln>
         </p:spPr>
+        <p:txBody>
+          <a:bodyPr/>
+          <a:lstStyle/>
+          <a:p>
+            <a:endParaRPr lang="en-US"/>
+          </a:p>
+        </p:txBody>
       </p:sp>
       <p:sp>
         <p:nvSpPr>
@@ -3710,7 +3580,7 @@
           <a:bodyPr wrap="square" lIns="0" tIns="0" rIns="0" bIns="0" rtlCol="0" anchor="t"/>
           <a:lstStyle/>
           <a:p>
-            <a:pPr algn="ctr" indent="0" marL="0">
+            <a:pPr marL="0" indent="0" algn="ctr">
               <a:buNone/>
             </a:pPr>
             <a:r>
@@ -3754,6 +3624,13 @@
             <a:prstDash val="solid"/>
           </a:ln>
         </p:spPr>
+        <p:txBody>
+          <a:bodyPr/>
+          <a:lstStyle/>
+          <a:p>
+            <a:endParaRPr lang="en-US"/>
+          </a:p>
+        </p:txBody>
       </p:sp>
       <p:sp>
         <p:nvSpPr>
@@ -3776,7 +3653,7 @@
           <a:bodyPr wrap="square" lIns="0" tIns="0" rIns="0" bIns="0" rtlCol="0" anchor="ctr"/>
           <a:lstStyle/>
           <a:p>
-            <a:pPr algn="ctr" indent="0" marL="0">
+            <a:pPr marL="0" indent="0" algn="ctr">
               <a:buNone/>
             </a:pPr>
             <a:r>
@@ -3815,7 +3692,7 @@
           <a:bodyPr wrap="square" lIns="0" tIns="0" rIns="0" bIns="0" rtlCol="0" anchor="ctr"/>
           <a:lstStyle/>
           <a:p>
-            <a:pPr algn="ctr" indent="0" marL="0">
+            <a:pPr marL="0" indent="0" algn="ctr">
               <a:buNone/>
             </a:pPr>
             <a:r>
@@ -3857,6 +3734,13 @@
             <a:prstDash val="solid"/>
           </a:ln>
         </p:spPr>
+        <p:txBody>
+          <a:bodyPr/>
+          <a:lstStyle/>
+          <a:p>
+            <a:endParaRPr lang="en-US"/>
+          </a:p>
+        </p:txBody>
       </p:sp>
       <p:sp>
         <p:nvSpPr>
@@ -3879,7 +3763,7 @@
           <a:bodyPr wrap="square" lIns="0" tIns="0" rIns="0" bIns="0" rtlCol="0" anchor="t"/>
           <a:lstStyle/>
           <a:p>
-            <a:pPr algn="ctr" indent="0" marL="0">
+            <a:pPr marL="0" indent="0" algn="ctr">
               <a:buNone/>
             </a:pPr>
             <a:r>
@@ -3921,6 +3805,13 @@
             <a:prstDash val="solid"/>
           </a:ln>
         </p:spPr>
+        <p:txBody>
+          <a:bodyPr/>
+          <a:lstStyle/>
+          <a:p>
+            <a:endParaRPr lang="en-US"/>
+          </a:p>
+        </p:txBody>
       </p:sp>
       <p:sp>
         <p:nvSpPr>
@@ -3943,7 +3834,7 @@
           <a:bodyPr wrap="square" lIns="0" tIns="0" rIns="0" bIns="0" rtlCol="0" anchor="t"/>
           <a:lstStyle/>
           <a:p>
-            <a:pPr algn="ctr" indent="0" marL="0">
+            <a:pPr marL="0" indent="0" algn="ctr">
               <a:buNone/>
             </a:pPr>
             <a:r>
@@ -3985,6 +3876,13 @@
             <a:prstDash val="solid"/>
           </a:ln>
         </p:spPr>
+        <p:txBody>
+          <a:bodyPr/>
+          <a:lstStyle/>
+          <a:p>
+            <a:endParaRPr lang="en-US"/>
+          </a:p>
+        </p:txBody>
       </p:sp>
       <p:sp>
         <p:nvSpPr>
@@ -4007,7 +3905,7 @@
           <a:bodyPr wrap="square" lIns="0" tIns="0" rIns="0" bIns="0" rtlCol="0" anchor="t"/>
           <a:lstStyle/>
           <a:p>
-            <a:pPr algn="ctr" indent="0" marL="0">
+            <a:pPr marL="0" indent="0" algn="ctr">
               <a:buNone/>
             </a:pPr>
             <a:r>
@@ -4049,6 +3947,13 @@
             <a:prstDash val="solid"/>
           </a:ln>
         </p:spPr>
+        <p:txBody>
+          <a:bodyPr/>
+          <a:lstStyle/>
+          <a:p>
+            <a:endParaRPr lang="en-US"/>
+          </a:p>
+        </p:txBody>
       </p:sp>
       <p:sp>
         <p:nvSpPr>
@@ -4071,7 +3976,7 @@
           <a:bodyPr wrap="square" lIns="0" tIns="0" rIns="0" bIns="0" rtlCol="0" anchor="t"/>
           <a:lstStyle/>
           <a:p>
-            <a:pPr algn="ctr" indent="0" marL="0">
+            <a:pPr marL="0" indent="0" algn="ctr">
               <a:buNone/>
             </a:pPr>
             <a:r>
@@ -4113,6 +4018,13 @@
             <a:prstDash val="solid"/>
           </a:ln>
         </p:spPr>
+        <p:txBody>
+          <a:bodyPr/>
+          <a:lstStyle/>
+          <a:p>
+            <a:endParaRPr lang="en-US"/>
+          </a:p>
+        </p:txBody>
       </p:sp>
       <p:sp>
         <p:nvSpPr>
@@ -4135,7 +4047,7 @@
           <a:bodyPr wrap="square" lIns="0" tIns="0" rIns="0" bIns="0" rtlCol="0" anchor="t"/>
           <a:lstStyle/>
           <a:p>
-            <a:pPr algn="ctr" indent="0" marL="0">
+            <a:pPr marL="0" indent="0" algn="ctr">
               <a:buNone/>
             </a:pPr>
             <a:r>
@@ -4177,6 +4089,13 @@
             <a:prstDash val="solid"/>
           </a:ln>
         </p:spPr>
+        <p:txBody>
+          <a:bodyPr/>
+          <a:lstStyle/>
+          <a:p>
+            <a:endParaRPr lang="en-US"/>
+          </a:p>
+        </p:txBody>
       </p:sp>
       <p:sp>
         <p:nvSpPr>
@@ -4199,7 +4118,7 @@
           <a:bodyPr wrap="square" lIns="0" tIns="0" rIns="0" bIns="0" rtlCol="0" anchor="t"/>
           <a:lstStyle/>
           <a:p>
-            <a:pPr algn="ctr" indent="0" marL="0">
+            <a:pPr marL="0" indent="0" algn="ctr">
               <a:buNone/>
             </a:pPr>
             <a:r>
@@ -4241,6 +4160,13 @@
             <a:prstDash val="solid"/>
           </a:ln>
         </p:spPr>
+        <p:txBody>
+          <a:bodyPr/>
+          <a:lstStyle/>
+          <a:p>
+            <a:endParaRPr lang="en-US"/>
+          </a:p>
+        </p:txBody>
       </p:sp>
       <p:sp>
         <p:nvSpPr>
@@ -4263,7 +4189,7 @@
           <a:bodyPr wrap="square" lIns="0" tIns="0" rIns="0" bIns="0" rtlCol="0" anchor="t"/>
           <a:lstStyle/>
           <a:p>
-            <a:pPr algn="ctr" indent="0" marL="0">
+            <a:pPr marL="0" indent="0" algn="ctr">
               <a:buNone/>
             </a:pPr>
             <a:r>
@@ -4307,6 +4233,13 @@
             <a:prstDash val="solid"/>
           </a:ln>
         </p:spPr>
+        <p:txBody>
+          <a:bodyPr/>
+          <a:lstStyle/>
+          <a:p>
+            <a:endParaRPr lang="en-US"/>
+          </a:p>
+        </p:txBody>
       </p:sp>
       <p:sp>
         <p:nvSpPr>
@@ -4329,7 +4262,7 @@
           <a:bodyPr wrap="square" lIns="0" tIns="0" rIns="0" bIns="0" rtlCol="0" anchor="ctr"/>
           <a:lstStyle/>
           <a:p>
-            <a:pPr algn="ctr" indent="0" marL="0">
+            <a:pPr marL="0" indent="0" algn="ctr">
               <a:buNone/>
             </a:pPr>
             <a:r>
@@ -4368,7 +4301,7 @@
           <a:bodyPr wrap="square" lIns="0" tIns="0" rIns="0" bIns="0" rtlCol="0" anchor="ctr"/>
           <a:lstStyle/>
           <a:p>
-            <a:pPr algn="ctr" indent="0" marL="0">
+            <a:pPr marL="0" indent="0" algn="ctr">
               <a:buNone/>
             </a:pPr>
             <a:r>
@@ -4410,6 +4343,13 @@
             <a:prstDash val="solid"/>
           </a:ln>
         </p:spPr>
+        <p:txBody>
+          <a:bodyPr/>
+          <a:lstStyle/>
+          <a:p>
+            <a:endParaRPr lang="en-US"/>
+          </a:p>
+        </p:txBody>
       </p:sp>
       <p:sp>
         <p:nvSpPr>
@@ -4432,7 +4372,7 @@
           <a:bodyPr wrap="square" lIns="0" tIns="0" rIns="0" bIns="0" rtlCol="0" anchor="t"/>
           <a:lstStyle/>
           <a:p>
-            <a:pPr algn="ctr" indent="0" marL="0">
+            <a:pPr marL="0" indent="0" algn="ctr">
               <a:buNone/>
             </a:pPr>
             <a:r>
@@ -4474,6 +4414,13 @@
             <a:prstDash val="solid"/>
           </a:ln>
         </p:spPr>
+        <p:txBody>
+          <a:bodyPr/>
+          <a:lstStyle/>
+          <a:p>
+            <a:endParaRPr lang="en-US"/>
+          </a:p>
+        </p:txBody>
       </p:sp>
       <p:sp>
         <p:nvSpPr>
@@ -4496,7 +4443,7 @@
           <a:bodyPr wrap="square" lIns="0" tIns="0" rIns="0" bIns="0" rtlCol="0" anchor="t"/>
           <a:lstStyle/>
           <a:p>
-            <a:pPr algn="ctr" indent="0" marL="0">
+            <a:pPr marL="0" indent="0" algn="ctr">
               <a:buNone/>
             </a:pPr>
             <a:r>
@@ -4538,6 +4485,13 @@
             <a:prstDash val="solid"/>
           </a:ln>
         </p:spPr>
+        <p:txBody>
+          <a:bodyPr/>
+          <a:lstStyle/>
+          <a:p>
+            <a:endParaRPr lang="en-US"/>
+          </a:p>
+        </p:txBody>
       </p:sp>
       <p:sp>
         <p:nvSpPr>
@@ -4560,7 +4514,7 @@
           <a:bodyPr wrap="square" lIns="0" tIns="0" rIns="0" bIns="0" rtlCol="0" anchor="t"/>
           <a:lstStyle/>
           <a:p>
-            <a:pPr algn="ctr" indent="0" marL="0">
+            <a:pPr marL="0" indent="0" algn="ctr">
               <a:buNone/>
             </a:pPr>
             <a:r>
@@ -4602,6 +4556,13 @@
             <a:prstDash val="solid"/>
           </a:ln>
         </p:spPr>
+        <p:txBody>
+          <a:bodyPr/>
+          <a:lstStyle/>
+          <a:p>
+            <a:endParaRPr lang="en-US"/>
+          </a:p>
+        </p:txBody>
       </p:sp>
       <p:sp>
         <p:nvSpPr>
@@ -4624,7 +4585,7 @@
           <a:bodyPr wrap="square" lIns="0" tIns="0" rIns="0" bIns="0" rtlCol="0" anchor="t"/>
           <a:lstStyle/>
           <a:p>
-            <a:pPr algn="ctr" indent="0" marL="0">
+            <a:pPr marL="0" indent="0" algn="ctr">
               <a:buNone/>
             </a:pPr>
             <a:r>
@@ -4668,6 +4629,13 @@
             <a:prstDash val="solid"/>
           </a:ln>
         </p:spPr>
+        <p:txBody>
+          <a:bodyPr/>
+          <a:lstStyle/>
+          <a:p>
+            <a:endParaRPr lang="en-US"/>
+          </a:p>
+        </p:txBody>
       </p:sp>
       <p:sp>
         <p:nvSpPr>
@@ -4690,7 +4658,7 @@
           <a:bodyPr wrap="square" lIns="0" tIns="0" rIns="0" bIns="0" rtlCol="0" anchor="ctr"/>
           <a:lstStyle/>
           <a:p>
-            <a:pPr algn="ctr" indent="0" marL="0">
+            <a:pPr marL="0" indent="0" algn="ctr">
               <a:buNone/>
             </a:pPr>
             <a:r>
@@ -4732,6 +4700,13 @@
             <a:prstDash val="solid"/>
           </a:ln>
         </p:spPr>
+        <p:txBody>
+          <a:bodyPr/>
+          <a:lstStyle/>
+          <a:p>
+            <a:endParaRPr lang="en-US"/>
+          </a:p>
+        </p:txBody>
       </p:sp>
       <p:sp>
         <p:nvSpPr>
@@ -4754,7 +4729,7 @@
           <a:bodyPr wrap="square" lIns="0" tIns="0" rIns="0" bIns="0" rtlCol="0" anchor="t"/>
           <a:lstStyle/>
           <a:p>
-            <a:pPr algn="ctr" indent="0" marL="0">
+            <a:pPr marL="0" indent="0" algn="ctr">
               <a:buNone/>
             </a:pPr>
             <a:r>
@@ -4796,6 +4771,13 @@
             <a:prstDash val="solid"/>
           </a:ln>
         </p:spPr>
+        <p:txBody>
+          <a:bodyPr/>
+          <a:lstStyle/>
+          <a:p>
+            <a:endParaRPr lang="en-US"/>
+          </a:p>
+        </p:txBody>
       </p:sp>
       <p:sp>
         <p:nvSpPr>
@@ -4818,7 +4800,7 @@
           <a:bodyPr wrap="square" lIns="0" tIns="0" rIns="0" bIns="0" rtlCol="0" anchor="t"/>
           <a:lstStyle/>
           <a:p>
-            <a:pPr algn="ctr" indent="0" marL="0">
+            <a:pPr marL="0" indent="0" algn="ctr">
               <a:buNone/>
             </a:pPr>
             <a:r>
@@ -4860,6 +4842,13 @@
             <a:prstDash val="solid"/>
           </a:ln>
         </p:spPr>
+        <p:txBody>
+          <a:bodyPr/>
+          <a:lstStyle/>
+          <a:p>
+            <a:endParaRPr lang="en-US"/>
+          </a:p>
+        </p:txBody>
       </p:sp>
       <p:sp>
         <p:nvSpPr>
@@ -4882,7 +4871,7 @@
           <a:bodyPr wrap="square" lIns="0" tIns="0" rIns="0" bIns="0" rtlCol="0" anchor="t"/>
           <a:lstStyle/>
           <a:p>
-            <a:pPr algn="ctr" indent="0" marL="0">
+            <a:pPr marL="0" indent="0" algn="ctr">
               <a:buNone/>
             </a:pPr>
             <a:r>
@@ -4924,6 +4913,13 @@
             <a:prstDash val="solid"/>
           </a:ln>
         </p:spPr>
+        <p:txBody>
+          <a:bodyPr/>
+          <a:lstStyle/>
+          <a:p>
+            <a:endParaRPr lang="en-US"/>
+          </a:p>
+        </p:txBody>
       </p:sp>
       <p:sp>
         <p:nvSpPr>
@@ -4946,7 +4942,7 @@
           <a:bodyPr wrap="square" lIns="0" tIns="0" rIns="0" bIns="0" rtlCol="0" anchor="t"/>
           <a:lstStyle/>
           <a:p>
-            <a:pPr algn="ctr" indent="0" marL="0">
+            <a:pPr marL="0" indent="0" algn="ctr">
               <a:buNone/>
             </a:pPr>
             <a:r>
@@ -4985,7 +4981,7 @@
           <a:bodyPr wrap="square" lIns="0" tIns="0" rIns="0" bIns="0" rtlCol="0" anchor="ctr"/>
           <a:lstStyle/>
           <a:p>
-            <a:pPr algn="ctr" indent="0" marL="0">
+            <a:pPr marL="0" indent="0" algn="ctr">
               <a:buNone/>
             </a:pPr>
             <a:r>
@@ -4999,7 +4995,7 @@
             <a:endParaRPr lang="en-US" sz="800" dirty="0"/>
           </a:p>
           <a:p>
-            <a:pPr algn="ctr" indent="0" marL="0">
+            <a:pPr marL="0" indent="0" algn="ctr">
               <a:buNone/>
             </a:pPr>
             <a:r>
@@ -5035,7 +5031,7 @@
           <a:bodyPr wrap="square" lIns="0" tIns="0" rIns="0" bIns="0" rtlCol="0" anchor="ctr"/>
           <a:lstStyle/>
           <a:p>
-            <a:pPr algn="ctr" indent="0" marL="0">
+            <a:pPr marL="0" indent="0" algn="ctr">
               <a:buNone/>
             </a:pPr>
             <a:r>
@@ -5072,6 +5068,13 @@
             <a:prstDash val="solid"/>
           </a:ln>
         </p:spPr>
+        <p:txBody>
+          <a:bodyPr/>
+          <a:lstStyle/>
+          <a:p>
+            <a:endParaRPr lang="en-US"/>
+          </a:p>
+        </p:txBody>
       </p:sp>
       <p:sp>
         <p:nvSpPr>
@@ -5095,6 +5098,13 @@
             <a:prstDash val="solid"/>
           </a:ln>
         </p:spPr>
+        <p:txBody>
+          <a:bodyPr/>
+          <a:lstStyle/>
+          <a:p>
+            <a:endParaRPr lang="en-US"/>
+          </a:p>
+        </p:txBody>
       </p:sp>
       <p:sp>
         <p:nvSpPr>
@@ -5118,6 +5128,13 @@
             <a:prstDash val="solid"/>
           </a:ln>
         </p:spPr>
+        <p:txBody>
+          <a:bodyPr/>
+          <a:lstStyle/>
+          <a:p>
+            <a:endParaRPr lang="en-US"/>
+          </a:p>
+        </p:txBody>
       </p:sp>
       <p:sp>
         <p:nvSpPr>
@@ -5141,6 +5158,13 @@
             <a:prstDash val="solid"/>
           </a:ln>
         </p:spPr>
+        <p:txBody>
+          <a:bodyPr/>
+          <a:lstStyle/>
+          <a:p>
+            <a:endParaRPr lang="en-US"/>
+          </a:p>
+        </p:txBody>
       </p:sp>
       <p:sp>
         <p:nvSpPr>
@@ -5164,6 +5188,13 @@
             <a:prstDash val="solid"/>
           </a:ln>
         </p:spPr>
+        <p:txBody>
+          <a:bodyPr/>
+          <a:lstStyle/>
+          <a:p>
+            <a:endParaRPr lang="en-US"/>
+          </a:p>
+        </p:txBody>
       </p:sp>
       <p:sp>
         <p:nvSpPr>
@@ -5187,6 +5218,13 @@
             <a:prstDash val="solid"/>
           </a:ln>
         </p:spPr>
+        <p:txBody>
+          <a:bodyPr/>
+          <a:lstStyle/>
+          <a:p>
+            <a:endParaRPr lang="en-US"/>
+          </a:p>
+        </p:txBody>
       </p:sp>
       <p:sp>
         <p:nvSpPr>
@@ -5210,6 +5248,13 @@
             <a:prstDash val="solid"/>
           </a:ln>
         </p:spPr>
+        <p:txBody>
+          <a:bodyPr/>
+          <a:lstStyle/>
+          <a:p>
+            <a:endParaRPr lang="en-US"/>
+          </a:p>
+        </p:txBody>
       </p:sp>
       <p:sp>
         <p:nvSpPr>
@@ -5233,6 +5278,13 @@
             <a:prstDash val="solid"/>
           </a:ln>
         </p:spPr>
+        <p:txBody>
+          <a:bodyPr/>
+          <a:lstStyle/>
+          <a:p>
+            <a:endParaRPr lang="en-US"/>
+          </a:p>
+        </p:txBody>
       </p:sp>
       <p:sp>
         <p:nvSpPr>
@@ -5256,6 +5308,13 @@
             <a:prstDash val="solid"/>
           </a:ln>
         </p:spPr>
+        <p:txBody>
+          <a:bodyPr/>
+          <a:lstStyle/>
+          <a:p>
+            <a:endParaRPr lang="en-US"/>
+          </a:p>
+        </p:txBody>
       </p:sp>
       <p:sp>
         <p:nvSpPr>
@@ -5279,6 +5338,13 @@
             <a:prstDash val="solid"/>
           </a:ln>
         </p:spPr>
+        <p:txBody>
+          <a:bodyPr/>
+          <a:lstStyle/>
+          <a:p>
+            <a:endParaRPr lang="en-US"/>
+          </a:p>
+        </p:txBody>
       </p:sp>
       <p:sp>
         <p:nvSpPr>
@@ -5302,6 +5368,13 @@
             <a:prstDash val="solid"/>
           </a:ln>
         </p:spPr>
+        <p:txBody>
+          <a:bodyPr/>
+          <a:lstStyle/>
+          <a:p>
+            <a:endParaRPr lang="en-US"/>
+          </a:p>
+        </p:txBody>
       </p:sp>
       <p:sp>
         <p:nvSpPr>
@@ -5325,6 +5398,13 @@
             <a:prstDash val="solid"/>
           </a:ln>
         </p:spPr>
+        <p:txBody>
+          <a:bodyPr/>
+          <a:lstStyle/>
+          <a:p>
+            <a:endParaRPr lang="en-US"/>
+          </a:p>
+        </p:txBody>
       </p:sp>
       <p:sp>
         <p:nvSpPr>
@@ -5348,6 +5428,13 @@
             <a:prstDash val="solid"/>
           </a:ln>
         </p:spPr>
+        <p:txBody>
+          <a:bodyPr/>
+          <a:lstStyle/>
+          <a:p>
+            <a:endParaRPr lang="en-US"/>
+          </a:p>
+        </p:txBody>
       </p:sp>
       <p:sp>
         <p:nvSpPr>
@@ -5371,6 +5458,13 @@
             <a:prstDash val="solid"/>
           </a:ln>
         </p:spPr>
+        <p:txBody>
+          <a:bodyPr/>
+          <a:lstStyle/>
+          <a:p>
+            <a:endParaRPr lang="en-US"/>
+          </a:p>
+        </p:txBody>
       </p:sp>
       <p:sp>
         <p:nvSpPr>
@@ -5394,6 +5488,13 @@
             <a:prstDash val="solid"/>
           </a:ln>
         </p:spPr>
+        <p:txBody>
+          <a:bodyPr/>
+          <a:lstStyle/>
+          <a:p>
+            <a:endParaRPr lang="en-US"/>
+          </a:p>
+        </p:txBody>
       </p:sp>
       <p:sp>
         <p:nvSpPr>
@@ -5417,6 +5518,13 @@
             <a:prstDash val="solid"/>
           </a:ln>
         </p:spPr>
+        <p:txBody>
+          <a:bodyPr/>
+          <a:lstStyle/>
+          <a:p>
+            <a:endParaRPr lang="en-US"/>
+          </a:p>
+        </p:txBody>
       </p:sp>
       <p:sp>
         <p:nvSpPr>
@@ -5440,6 +5548,13 @@
             <a:prstDash val="solid"/>
           </a:ln>
         </p:spPr>
+        <p:txBody>
+          <a:bodyPr/>
+          <a:lstStyle/>
+          <a:p>
+            <a:endParaRPr lang="en-US"/>
+          </a:p>
+        </p:txBody>
       </p:sp>
       <p:sp>
         <p:nvSpPr>
@@ -5463,6 +5578,13 @@
             <a:prstDash val="solid"/>
           </a:ln>
         </p:spPr>
+        <p:txBody>
+          <a:bodyPr/>
+          <a:lstStyle/>
+          <a:p>
+            <a:endParaRPr lang="en-US"/>
+          </a:p>
+        </p:txBody>
       </p:sp>
       <p:sp>
         <p:nvSpPr>
@@ -5486,6 +5608,13 @@
             <a:prstDash val="solid"/>
           </a:ln>
         </p:spPr>
+        <p:txBody>
+          <a:bodyPr/>
+          <a:lstStyle/>
+          <a:p>
+            <a:endParaRPr lang="en-US"/>
+          </a:p>
+        </p:txBody>
       </p:sp>
       <p:sp>
         <p:nvSpPr>
@@ -5509,6 +5638,13 @@
             <a:prstDash val="solid"/>
           </a:ln>
         </p:spPr>
+        <p:txBody>
+          <a:bodyPr/>
+          <a:lstStyle/>
+          <a:p>
+            <a:endParaRPr lang="en-US"/>
+          </a:p>
+        </p:txBody>
       </p:sp>
       <p:sp>
         <p:nvSpPr>
@@ -5519,7 +5655,7 @@
         <p:spPr>
           <a:xfrm>
             <a:off x="2726152" y="4937760"/>
-            <a:ext cx="0" cy="-2455164"/>
+            <a:ext cx="0" cy="0"/>
           </a:xfrm>
           <a:prstGeom prst="line">
             <a:avLst/>
@@ -5532,6 +5668,13 @@
             <a:prstDash val="solid"/>
           </a:ln>
         </p:spPr>
+        <p:txBody>
+          <a:bodyPr/>
+          <a:lstStyle/>
+          <a:p>
+            <a:endParaRPr lang="en-US"/>
+          </a:p>
+        </p:txBody>
       </p:sp>
       <p:sp>
         <p:nvSpPr>
@@ -5542,7 +5685,7 @@
         <p:spPr>
           <a:xfrm>
             <a:off x="2726152" y="4937760"/>
-            <a:ext cx="0" cy="-2455164"/>
+            <a:ext cx="0" cy="0"/>
           </a:xfrm>
           <a:prstGeom prst="line">
             <a:avLst/>
@@ -5555,6 +5698,13 @@
             <a:prstDash val="solid"/>
           </a:ln>
         </p:spPr>
+        <p:txBody>
+          <a:bodyPr/>
+          <a:lstStyle/>
+          <a:p>
+            <a:endParaRPr lang="en-US"/>
+          </a:p>
+        </p:txBody>
       </p:sp>
       <p:sp>
         <p:nvSpPr>
@@ -5565,7 +5715,7 @@
         <p:spPr>
           <a:xfrm>
             <a:off x="2907482" y="4937760"/>
-            <a:ext cx="0" cy="-2455164"/>
+            <a:ext cx="0" cy="0"/>
           </a:xfrm>
           <a:prstGeom prst="line">
             <a:avLst/>
@@ -5578,6 +5728,13 @@
             <a:prstDash val="solid"/>
           </a:ln>
         </p:spPr>
+        <p:txBody>
+          <a:bodyPr/>
+          <a:lstStyle/>
+          <a:p>
+            <a:endParaRPr lang="en-US"/>
+          </a:p>
+        </p:txBody>
       </p:sp>
       <p:sp>
         <p:nvSpPr>
@@ -5588,7 +5745,7 @@
         <p:spPr>
           <a:xfrm>
             <a:off x="2544822" y="4937760"/>
-            <a:ext cx="0" cy="-566928"/>
+            <a:ext cx="0" cy="0"/>
           </a:xfrm>
           <a:prstGeom prst="line">
             <a:avLst/>
@@ -5601,6 +5758,13 @@
             <a:prstDash val="dash"/>
           </a:ln>
         </p:spPr>
+        <p:txBody>
+          <a:bodyPr/>
+          <a:lstStyle/>
+          <a:p>
+            <a:endParaRPr lang="en-US"/>
+          </a:p>
+        </p:txBody>
       </p:sp>
       <p:sp>
         <p:nvSpPr>
@@ -5628,6 +5792,13 @@
             <a:prstDash val="solid"/>
           </a:ln>
         </p:spPr>
+        <p:txBody>
+          <a:bodyPr/>
+          <a:lstStyle/>
+          <a:p>
+            <a:endParaRPr lang="en-US"/>
+          </a:p>
+        </p:txBody>
       </p:sp>
       <p:sp>
         <p:nvSpPr>
@@ -5650,7 +5821,7 @@
           <a:bodyPr wrap="square" lIns="0" tIns="0" rIns="0" bIns="0" rtlCol="0" anchor="ctr"/>
           <a:lstStyle/>
           <a:p>
-            <a:pPr algn="ctr" indent="0" marL="0">
+            <a:pPr marL="0" indent="0" algn="ctr">
               <a:buNone/>
             </a:pPr>
             <a:r>
@@ -5689,7 +5860,7 @@
           <a:bodyPr wrap="square" lIns="0" tIns="0" rIns="0" bIns="0" rtlCol="0" anchor="ctr"/>
           <a:lstStyle/>
           <a:p>
-            <a:pPr algn="ctr" indent="0" marL="0">
+            <a:pPr marL="0" indent="0" algn="ctr">
               <a:buNone/>
             </a:pPr>
             <a:r>
@@ -5728,7 +5899,7 @@
           <a:bodyPr wrap="square" lIns="0" tIns="0" rIns="0" bIns="0" rtlCol="0" anchor="ctr"/>
           <a:lstStyle/>
           <a:p>
-            <a:pPr algn="ctr" indent="0" marL="0">
+            <a:pPr marL="0" indent="0" algn="ctr">
               <a:buNone/>
             </a:pPr>
             <a:r>
@@ -5767,7 +5938,7 @@
           <a:bodyPr wrap="square" lIns="0" tIns="0" rIns="0" bIns="0" rtlCol="0" anchor="ctr"/>
           <a:lstStyle/>
           <a:p>
-            <a:pPr indent="0" marL="0">
+            <a:pPr marL="0" indent="0">
               <a:buNone/>
             </a:pPr>
             <a:r>
@@ -5809,6 +5980,13 @@
             <a:prstDash val="solid"/>
           </a:ln>
         </p:spPr>
+        <p:txBody>
+          <a:bodyPr/>
+          <a:lstStyle/>
+          <a:p>
+            <a:endParaRPr lang="en-US"/>
+          </a:p>
+        </p:txBody>
       </p:sp>
       <p:sp>
         <p:nvSpPr>
@@ -5831,7 +6009,7 @@
           <a:bodyPr wrap="square" lIns="0" tIns="0" rIns="0" bIns="0" rtlCol="0" anchor="ctr"/>
           <a:lstStyle/>
           <a:p>
-            <a:pPr indent="0" marL="0">
+            <a:pPr marL="0" indent="0">
               <a:buNone/>
             </a:pPr>
             <a:r>
@@ -5870,7 +6048,7 @@
           <a:bodyPr wrap="square" lIns="0" tIns="0" rIns="0" bIns="0" rtlCol="0" anchor="ctr"/>
           <a:lstStyle/>
           <a:p>
-            <a:pPr indent="0" marL="0">
+            <a:pPr marL="0" indent="0">
               <a:buNone/>
             </a:pPr>
             <a:r>
@@ -5909,7 +6087,7 @@
           <a:bodyPr wrap="square" lIns="0" tIns="0" rIns="0" bIns="0" rtlCol="0" anchor="ctr"/>
           <a:lstStyle/>
           <a:p>
-            <a:pPr indent="0" marL="0">
+            <a:pPr marL="0" indent="0">
               <a:buNone/>
             </a:pPr>
             <a:r>
@@ -5949,6 +6127,13 @@
             <a:prstDash val="solid"/>
           </a:ln>
         </p:spPr>
+        <p:txBody>
+          <a:bodyPr/>
+          <a:lstStyle/>
+          <a:p>
+            <a:endParaRPr lang="en-US"/>
+          </a:p>
+        </p:txBody>
       </p:sp>
       <p:sp>
         <p:nvSpPr>
@@ -5971,7 +6156,7 @@
           <a:bodyPr wrap="square" lIns="0" tIns="0" rIns="0" bIns="0" rtlCol="0" anchor="ctr"/>
           <a:lstStyle/>
           <a:p>
-            <a:pPr indent="0" marL="0">
+            <a:pPr marL="0" indent="0">
               <a:buNone/>
             </a:pPr>
             <a:r>
@@ -6011,6 +6196,13 @@
             <a:prstDash val="solid"/>
           </a:ln>
         </p:spPr>
+        <p:txBody>
+          <a:bodyPr/>
+          <a:lstStyle/>
+          <a:p>
+            <a:endParaRPr lang="en-US"/>
+          </a:p>
+        </p:txBody>
       </p:sp>
       <p:sp>
         <p:nvSpPr>
@@ -6033,7 +6225,7 @@
           <a:bodyPr wrap="square" lIns="0" tIns="0" rIns="0" bIns="0" rtlCol="0" anchor="ctr"/>
           <a:lstStyle/>
           <a:p>
-            <a:pPr indent="0" marL="0">
+            <a:pPr marL="0" indent="0">
               <a:buNone/>
             </a:pPr>
             <a:r>
@@ -6073,6 +6265,13 @@
             <a:prstDash val="solid"/>
           </a:ln>
         </p:spPr>
+        <p:txBody>
+          <a:bodyPr/>
+          <a:lstStyle/>
+          <a:p>
+            <a:endParaRPr lang="en-US"/>
+          </a:p>
+        </p:txBody>
       </p:sp>
       <p:sp>
         <p:nvSpPr>
@@ -6095,7 +6294,7 @@
           <a:bodyPr wrap="square" lIns="0" tIns="0" rIns="0" bIns="0" rtlCol="0" anchor="ctr"/>
           <a:lstStyle/>
           <a:p>
-            <a:pPr indent="0" marL="0">
+            <a:pPr marL="0" indent="0">
               <a:buNone/>
             </a:pPr>
             <a:r>
@@ -6135,6 +6334,13 @@
             <a:prstDash val="solid"/>
           </a:ln>
         </p:spPr>
+        <p:txBody>
+          <a:bodyPr/>
+          <a:lstStyle/>
+          <a:p>
+            <a:endParaRPr lang="en-US"/>
+          </a:p>
+        </p:txBody>
       </p:sp>
       <p:sp>
         <p:nvSpPr>
@@ -6157,7 +6363,7 @@
           <a:bodyPr wrap="square" lIns="0" tIns="0" rIns="0" bIns="0" rtlCol="0" anchor="ctr"/>
           <a:lstStyle/>
           <a:p>
-            <a:pPr indent="0" marL="0">
+            <a:pPr marL="0" indent="0">
               <a:buNone/>
             </a:pPr>
             <a:r>
@@ -6197,6 +6403,13 @@
             <a:prstDash val="solid"/>
           </a:ln>
         </p:spPr>
+        <p:txBody>
+          <a:bodyPr/>
+          <a:lstStyle/>
+          <a:p>
+            <a:endParaRPr lang="en-US"/>
+          </a:p>
+        </p:txBody>
       </p:sp>
       <p:sp>
         <p:nvSpPr>
@@ -6220,6 +6433,13 @@
             <a:prstDash val="solid"/>
           </a:ln>
         </p:spPr>
+        <p:txBody>
+          <a:bodyPr/>
+          <a:lstStyle/>
+          <a:p>
+            <a:endParaRPr lang="en-US"/>
+          </a:p>
+        </p:txBody>
       </p:sp>
       <p:sp>
         <p:nvSpPr>
@@ -6242,7 +6462,7 @@
           <a:bodyPr wrap="square" lIns="0" tIns="0" rIns="0" bIns="0" rtlCol="0" anchor="ctr"/>
           <a:lstStyle/>
           <a:p>
-            <a:pPr indent="0" marL="0">
+            <a:pPr marL="0" indent="0">
               <a:buNone/>
             </a:pPr>
             <a:r>
@@ -6282,6 +6502,13 @@
             <a:prstDash val="dash"/>
           </a:ln>
         </p:spPr>
+        <p:txBody>
+          <a:bodyPr/>
+          <a:lstStyle/>
+          <a:p>
+            <a:endParaRPr lang="en-US"/>
+          </a:p>
+        </p:txBody>
       </p:sp>
       <p:sp>
         <p:nvSpPr>
@@ -6304,7 +6531,7 @@
           <a:bodyPr wrap="square" lIns="0" tIns="0" rIns="0" bIns="0" rtlCol="0" anchor="ctr"/>
           <a:lstStyle/>
           <a:p>
-            <a:pPr indent="0" marL="0">
+            <a:pPr marL="0" indent="0">
               <a:buNone/>
             </a:pPr>
             <a:r>
@@ -6343,7 +6570,7 @@
           <a:bodyPr wrap="square" lIns="0" tIns="0" rIns="0" bIns="0" rtlCol="0" anchor="ctr"/>
           <a:lstStyle/>
           <a:p>
-            <a:pPr indent="0" marL="0">
+            <a:pPr marL="0" indent="0">
               <a:buNone/>
             </a:pPr>
             <a:r>
@@ -6382,7 +6609,7 @@
           <a:bodyPr wrap="square" lIns="0" tIns="0" rIns="0" bIns="0" rtlCol="0" anchor="ctr"/>
           <a:lstStyle/>
           <a:p>
-            <a:pPr indent="0" marL="0">
+            <a:pPr marL="0" indent="0">
               <a:buNone/>
             </a:pPr>
             <a:r>
@@ -6421,7 +6648,7 @@
           <a:bodyPr wrap="square" lIns="0" tIns="0" rIns="0" bIns="0" rtlCol="0" anchor="ctr"/>
           <a:lstStyle/>
           <a:p>
-            <a:pPr indent="0" marL="0">
+            <a:pPr marL="0" indent="0">
               <a:buNone/>
             </a:pPr>
             <a:r>
@@ -6460,7 +6687,7 @@
           <a:bodyPr wrap="square" lIns="0" tIns="0" rIns="0" bIns="0" rtlCol="0" anchor="ctr"/>
           <a:lstStyle/>
           <a:p>
-            <a:pPr indent="0" marL="0">
+            <a:pPr marL="0" indent="0">
               <a:buNone/>
             </a:pPr>
             <a:r>
@@ -6499,7 +6726,7 @@
           <a:bodyPr wrap="square" lIns="0" tIns="0" rIns="0" bIns="0" rtlCol="0" anchor="ctr"/>
           <a:lstStyle/>
           <a:p>
-            <a:pPr indent="0" marL="0">
+            <a:pPr marL="0" indent="0">
               <a:buNone/>
             </a:pPr>
             <a:r>
@@ -6538,7 +6765,7 @@
           <a:bodyPr wrap="square" lIns="0" tIns="0" rIns="0" bIns="0" rtlCol="0" anchor="ctr"/>
           <a:lstStyle/>
           <a:p>
-            <a:pPr indent="0" marL="0">
+            <a:pPr marL="0" indent="0">
               <a:buNone/>
             </a:pPr>
             <a:r>
@@ -6577,7 +6804,7 @@
           <a:bodyPr wrap="square" lIns="0" tIns="0" rIns="0" bIns="0" rtlCol="0" anchor="ctr"/>
           <a:lstStyle/>
           <a:p>
-            <a:pPr indent="0" marL="0">
+            <a:pPr marL="0" indent="0">
               <a:buNone/>
             </a:pPr>
             <a:r>
@@ -6616,7 +6843,7 @@
           <a:bodyPr wrap="square" lIns="0" tIns="0" rIns="0" bIns="0" rtlCol="0" anchor="ctr"/>
           <a:lstStyle/>
           <a:p>
-            <a:pPr indent="0" marL="0">
+            <a:pPr marL="0" indent="0">
               <a:buNone/>
             </a:pPr>
             <a:r>
@@ -6629,45 +6856,6 @@
                 <a:cs typeface="Calibri" pitchFamily="34" charset="-120"/>
               </a:rPr>
               <a:t>• MS5837 sealed via 1.8×0.8 mm O-ring</a:t>
-            </a:r>
-            <a:endParaRPr lang="en-US" sz="900" dirty="0"/>
-          </a:p>
-        </p:txBody>
-      </p:sp>
-      <p:sp>
-        <p:nvSpPr>
-          <p:cNvPr id="176" name="Text 174"/>
-          <p:cNvSpPr/>
-          <p:nvPr/>
-        </p:nvSpPr>
-        <p:spPr>
-          <a:xfrm>
-            <a:off x="457200" y="6565392"/>
-            <a:ext cx="11247120" cy="201168"/>
-          </a:xfrm>
-          <a:prstGeom prst="rect">
-            <a:avLst/>
-          </a:prstGeom>
-          <a:noFill/>
-          <a:ln/>
-        </p:spPr>
-        <p:txBody>
-          <a:bodyPr wrap="square" lIns="0" tIns="0" rIns="0" bIns="0" rtlCol="0" anchor="ctr"/>
-          <a:lstStyle/>
-          <a:p>
-            <a:pPr indent="0" marL="0">
-              <a:buNone/>
-            </a:pPr>
-            <a:r>
-              <a:rPr lang="en-US" sz="900" i="1" dirty="0">
-                <a:solidFill>
-                  <a:srgbClr val="6B7280"/>
-                </a:solidFill>
-                <a:latin typeface="Calibri" pitchFamily="34" charset="0"/>
-                <a:ea typeface="Calibri" pitchFamily="34" charset="-122"/>
-                <a:cs typeface="Calibri" pitchFamily="34" charset="-120"/>
-              </a:rPr>
-              <a:t>PARcast — github.com/LoriAzniveBerberian/PARcast</a:t>
             </a:r>
             <a:endParaRPr lang="en-US" sz="900" dirty="0"/>
           </a:p>
@@ -6689,6 +6877,7 @@
         <a:solidFill>
           <a:srgbClr val="FFFFFF"/>
         </a:solidFill>
+        <a:effectLst/>
       </p:bgPr>
     </p:bg>
     <p:spTree>
@@ -6726,7 +6915,7 @@
           <a:bodyPr wrap="square" lIns="0" tIns="0" rIns="0" bIns="0" rtlCol="0" anchor="ctr"/>
           <a:lstStyle/>
           <a:p>
-            <a:pPr indent="0" marL="0">
+            <a:pPr marL="0" indent="0">
               <a:buNone/>
             </a:pPr>
             <a:r>
@@ -6765,7 +6954,7 @@
           <a:bodyPr wrap="square" lIns="0" tIns="0" rIns="0" bIns="0" rtlCol="0" anchor="ctr"/>
           <a:lstStyle/>
           <a:p>
-            <a:pPr indent="0" marL="0">
+            <a:pPr marL="0" indent="0">
               <a:buNone/>
             </a:pPr>
             <a:r>
@@ -6777,7 +6966,7 @@
                 <a:ea typeface="Calibri" pitchFamily="34" charset="-122"/>
                 <a:cs typeface="Calibri" pitchFamily="34" charset="-120"/>
               </a:rPr>
-              <a:t>Authoritative pin-by-pin reference for build and debug</a:t>
+              <a:t>Authoritative pin-by-pin reference for build</a:t>
             </a:r>
             <a:endParaRPr lang="en-US" sz="1200" dirty="0"/>
           </a:p>
@@ -6785,33 +6974,69 @@
       </p:sp>
       <p:graphicFrame>
         <p:nvGraphicFramePr>
-          <p:cNvPr id="3" name="Table 0"/>
+          <p:cNvPr id="4" name="Table 0"/>
           <p:cNvGraphicFramePr>
             <a:graphicFrameLocks noGrp="1"/>
           </p:cNvGraphicFramePr>
           <p:nvPr>
             <p:extLst>
               <p:ext uri="{D42A27DB-BD31-4B8C-83A1-F6EECF244321}">
-                <p14:modId xmlns:p14="http://schemas.microsoft.com/office/powerpoint/2010/main" val="1579011935"/>
+                <p14:modId xmlns:p14="http://schemas.microsoft.com/office/powerpoint/2010/main" val="2769878173"/>
               </p:ext>
             </p:extLst>
           </p:nvPr>
         </p:nvGraphicFramePr>
         <p:xfrm>
-          <a:off x="457200" y="1005840"/>
-          <a:ext cx="11247120" cy="914400"/>
+          <a:off x="472440" y="1062228"/>
+          <a:ext cx="11247120" cy="4733544"/>
         </p:xfrm>
         <a:graphic>
           <a:graphicData uri="http://schemas.openxmlformats.org/drawingml/2006/table">
             <a:tbl>
               <a:tblPr/>
               <a:tblGrid>
-                <a:gridCol w="1371600"/>
-                <a:gridCol w="1645920"/>
-                <a:gridCol w="1554480"/>
-                <a:gridCol w="1371600"/>
-                <a:gridCol w="1463040"/>
-                <a:gridCol w="3840480"/>
+                <a:gridCol w="1371600">
+                  <a:extLst>
+                    <a:ext uri="{9D8B030D-6E8A-4147-A177-3AD203B41FA5}">
+                      <a16:colId xmlns:a16="http://schemas.microsoft.com/office/drawing/2014/main" val="20000"/>
+                    </a:ext>
+                  </a:extLst>
+                </a:gridCol>
+                <a:gridCol w="1645920">
+                  <a:extLst>
+                    <a:ext uri="{9D8B030D-6E8A-4147-A177-3AD203B41FA5}">
+                      <a16:colId xmlns:a16="http://schemas.microsoft.com/office/drawing/2014/main" val="20001"/>
+                    </a:ext>
+                  </a:extLst>
+                </a:gridCol>
+                <a:gridCol w="1554480">
+                  <a:extLst>
+                    <a:ext uri="{9D8B030D-6E8A-4147-A177-3AD203B41FA5}">
+                      <a16:colId xmlns:a16="http://schemas.microsoft.com/office/drawing/2014/main" val="20002"/>
+                    </a:ext>
+                  </a:extLst>
+                </a:gridCol>
+                <a:gridCol w="1371600">
+                  <a:extLst>
+                    <a:ext uri="{9D8B030D-6E8A-4147-A177-3AD203B41FA5}">
+                      <a16:colId xmlns:a16="http://schemas.microsoft.com/office/drawing/2014/main" val="20003"/>
+                    </a:ext>
+                  </a:extLst>
+                </a:gridCol>
+                <a:gridCol w="1463040">
+                  <a:extLst>
+                    <a:ext uri="{9D8B030D-6E8A-4147-A177-3AD203B41FA5}">
+                      <a16:colId xmlns:a16="http://schemas.microsoft.com/office/drawing/2014/main" val="20004"/>
+                    </a:ext>
+                  </a:extLst>
+                </a:gridCol>
+                <a:gridCol w="3840480">
+                  <a:extLst>
+                    <a:ext uri="{9D8B030D-6E8A-4147-A177-3AD203B41FA5}">
+                      <a16:colId xmlns:a16="http://schemas.microsoft.com/office/drawing/2014/main" val="20005"/>
+                    </a:ext>
+                  </a:extLst>
+                </a:gridCol>
               </a:tblGrid>
               <a:tr h="201168">
                 <a:tc>
@@ -6819,7 +7044,7 @@
                     <a:bodyPr/>
                     <a:lstStyle/>
                     <a:p>
-                      <a:pPr algn="l" indent="0" marL="0">
+                      <a:pPr marL="0" indent="0" algn="l">
                         <a:buNone/>
                       </a:pPr>
                       <a:r>
@@ -6887,7 +7112,7 @@
                     <a:bodyPr/>
                     <a:lstStyle/>
                     <a:p>
-                      <a:pPr algn="l" indent="0" marL="0">
+                      <a:pPr marL="0" indent="0" algn="l">
                         <a:buNone/>
                       </a:pPr>
                       <a:r>
@@ -6955,7 +7180,7 @@
                     <a:bodyPr/>
                     <a:lstStyle/>
                     <a:p>
-                      <a:pPr algn="l" indent="0" marL="0">
+                      <a:pPr marL="0" indent="0" algn="l">
                         <a:buNone/>
                       </a:pPr>
                       <a:r>
@@ -7023,7 +7248,7 @@
                     <a:bodyPr/>
                     <a:lstStyle/>
                     <a:p>
-                      <a:pPr algn="l" indent="0" marL="0">
+                      <a:pPr marL="0" indent="0" algn="l">
                         <a:buNone/>
                       </a:pPr>
                       <a:r>
@@ -7091,7 +7316,7 @@
                     <a:bodyPr/>
                     <a:lstStyle/>
                     <a:p>
-                      <a:pPr algn="l" indent="0" marL="0">
+                      <a:pPr marL="0" indent="0" algn="l">
                         <a:buNone/>
                       </a:pPr>
                       <a:r>
@@ -7159,7 +7384,7 @@
                     <a:bodyPr/>
                     <a:lstStyle/>
                     <a:p>
-                      <a:pPr algn="l" indent="0" marL="0">
+                      <a:pPr marL="0" indent="0" algn="l">
                         <a:buNone/>
                       </a:pPr>
                       <a:r>
@@ -7222,6 +7447,11 @@
                     </a:solidFill>
                   </a:tcPr>
                 </a:tc>
+                <a:extLst>
+                  <a:ext uri="{0D108BD9-81ED-4DB2-BD59-A6C34878D82A}">
+                    <a16:rowId xmlns:a16="http://schemas.microsoft.com/office/drawing/2014/main" val="10000"/>
+                  </a:ext>
+                </a:extLst>
               </a:tr>
               <a:tr h="201168">
                 <a:tc>
@@ -7229,7 +7459,7 @@
                     <a:bodyPr/>
                     <a:lstStyle/>
                     <a:p>
-                      <a:pPr indent="0" marL="0">
+                      <a:pPr marL="0" indent="0">
                         <a:buNone/>
                       </a:pPr>
                       <a:r>
@@ -7294,7 +7524,7 @@
                     <a:bodyPr/>
                     <a:lstStyle/>
                     <a:p>
-                      <a:pPr indent="0" marL="0">
+                      <a:pPr marL="0" indent="0">
                         <a:buNone/>
                       </a:pPr>
                       <a:r>
@@ -7359,7 +7589,7 @@
                     <a:bodyPr/>
                     <a:lstStyle/>
                     <a:p>
-                      <a:pPr indent="0" marL="0">
+                      <a:pPr marL="0" indent="0">
                         <a:buNone/>
                       </a:pPr>
                       <a:r>
@@ -7424,7 +7654,7 @@
                     <a:bodyPr/>
                     <a:lstStyle/>
                     <a:p>
-                      <a:pPr indent="0" marL="0">
+                      <a:pPr marL="0" indent="0">
                         <a:buNone/>
                       </a:pPr>
                       <a:r>
@@ -7489,7 +7719,7 @@
                     <a:bodyPr/>
                     <a:lstStyle/>
                     <a:p>
-                      <a:pPr indent="0" marL="0">
+                      <a:pPr marL="0" indent="0">
                         <a:buNone/>
                       </a:pPr>
                       <a:r>
@@ -7554,7 +7784,7 @@
                     <a:bodyPr/>
                     <a:lstStyle/>
                     <a:p>
-                      <a:pPr indent="0" marL="0">
+                      <a:pPr marL="0" indent="0">
                         <a:buNone/>
                       </a:pPr>
                       <a:r>
@@ -7614,6 +7844,11 @@
                     </a:lnB>
                   </a:tcPr>
                 </a:tc>
+                <a:extLst>
+                  <a:ext uri="{0D108BD9-81ED-4DB2-BD59-A6C34878D82A}">
+                    <a16:rowId xmlns:a16="http://schemas.microsoft.com/office/drawing/2014/main" val="10001"/>
+                  </a:ext>
+                </a:extLst>
               </a:tr>
               <a:tr h="201168">
                 <a:tc>
@@ -7621,7 +7856,7 @@
                     <a:bodyPr/>
                     <a:lstStyle/>
                     <a:p>
-                      <a:pPr indent="0" marL="0">
+                      <a:pPr marL="0" indent="0">
                         <a:buNone/>
                       </a:pPr>
                       <a:r>
@@ -7686,7 +7921,7 @@
                     <a:bodyPr/>
                     <a:lstStyle/>
                     <a:p>
-                      <a:pPr indent="0" marL="0">
+                      <a:pPr marL="0" indent="0">
                         <a:buNone/>
                       </a:pPr>
                       <a:r>
@@ -7751,7 +7986,7 @@
                     <a:bodyPr/>
                     <a:lstStyle/>
                     <a:p>
-                      <a:pPr indent="0" marL="0">
+                      <a:pPr marL="0" indent="0">
                         <a:buNone/>
                       </a:pPr>
                       <a:r>
@@ -7816,7 +8051,7 @@
                     <a:bodyPr/>
                     <a:lstStyle/>
                     <a:p>
-                      <a:pPr indent="0" marL="0">
+                      <a:pPr marL="0" indent="0">
                         <a:buNone/>
                       </a:pPr>
                       <a:r>
@@ -7881,7 +8116,7 @@
                     <a:bodyPr/>
                     <a:lstStyle/>
                     <a:p>
-                      <a:pPr indent="0" marL="0">
+                      <a:pPr marL="0" indent="0">
                         <a:buNone/>
                       </a:pPr>
                       <a:r>
@@ -7946,7 +8181,7 @@
                     <a:bodyPr/>
                     <a:lstStyle/>
                     <a:p>
-                      <a:pPr indent="0" marL="0">
+                      <a:pPr marL="0" indent="0">
                         <a:buNone/>
                       </a:pPr>
                       <a:r>
@@ -8006,6 +8241,11 @@
                     </a:lnB>
                   </a:tcPr>
                 </a:tc>
+                <a:extLst>
+                  <a:ext uri="{0D108BD9-81ED-4DB2-BD59-A6C34878D82A}">
+                    <a16:rowId xmlns:a16="http://schemas.microsoft.com/office/drawing/2014/main" val="10002"/>
+                  </a:ext>
+                </a:extLst>
               </a:tr>
               <a:tr h="201168">
                 <a:tc>
@@ -8013,7 +8253,7 @@
                     <a:bodyPr/>
                     <a:lstStyle/>
                     <a:p>
-                      <a:pPr indent="0" marL="0">
+                      <a:pPr marL="0" indent="0">
                         <a:buNone/>
                       </a:pPr>
                       <a:r>
@@ -8078,7 +8318,7 @@
                     <a:bodyPr/>
                     <a:lstStyle/>
                     <a:p>
-                      <a:pPr indent="0" marL="0">
+                      <a:pPr marL="0" indent="0">
                         <a:buNone/>
                       </a:pPr>
                       <a:r>
@@ -8143,7 +8383,7 @@
                     <a:bodyPr/>
                     <a:lstStyle/>
                     <a:p>
-                      <a:pPr indent="0" marL="0">
+                      <a:pPr marL="0" indent="0">
                         <a:buNone/>
                       </a:pPr>
                       <a:r>
@@ -8208,7 +8448,7 @@
                     <a:bodyPr/>
                     <a:lstStyle/>
                     <a:p>
-                      <a:pPr indent="0" marL="0">
+                      <a:pPr marL="0" indent="0">
                         <a:buNone/>
                       </a:pPr>
                       <a:r>
@@ -8273,7 +8513,7 @@
                     <a:bodyPr/>
                     <a:lstStyle/>
                     <a:p>
-                      <a:pPr indent="0" marL="0">
+                      <a:pPr marL="0" indent="0">
                         <a:buNone/>
                       </a:pPr>
                       <a:r>
@@ -8338,7 +8578,7 @@
                     <a:bodyPr/>
                     <a:lstStyle/>
                     <a:p>
-                      <a:pPr indent="0" marL="0">
+                      <a:pPr marL="0" indent="0">
                         <a:buNone/>
                       </a:pPr>
                       <a:r>
@@ -8398,6 +8638,11 @@
                     </a:lnB>
                   </a:tcPr>
                 </a:tc>
+                <a:extLst>
+                  <a:ext uri="{0D108BD9-81ED-4DB2-BD59-A6C34878D82A}">
+                    <a16:rowId xmlns:a16="http://schemas.microsoft.com/office/drawing/2014/main" val="10003"/>
+                  </a:ext>
+                </a:extLst>
               </a:tr>
               <a:tr h="201168">
                 <a:tc>
@@ -8405,7 +8650,7 @@
                     <a:bodyPr/>
                     <a:lstStyle/>
                     <a:p>
-                      <a:pPr indent="0" marL="0">
+                      <a:pPr marL="0" indent="0">
                         <a:buNone/>
                       </a:pPr>
                       <a:r>
@@ -8470,7 +8715,7 @@
                     <a:bodyPr/>
                     <a:lstStyle/>
                     <a:p>
-                      <a:pPr indent="0" marL="0">
+                      <a:pPr marL="0" indent="0">
                         <a:buNone/>
                       </a:pPr>
                       <a:r>
@@ -8535,7 +8780,7 @@
                     <a:bodyPr/>
                     <a:lstStyle/>
                     <a:p>
-                      <a:pPr indent="0" marL="0">
+                      <a:pPr marL="0" indent="0">
                         <a:buNone/>
                       </a:pPr>
                       <a:r>
@@ -8600,7 +8845,7 @@
                     <a:bodyPr/>
                     <a:lstStyle/>
                     <a:p>
-                      <a:pPr indent="0" marL="0">
+                      <a:pPr marL="0" indent="0">
                         <a:buNone/>
                       </a:pPr>
                       <a:r>
@@ -8665,7 +8910,7 @@
                     <a:bodyPr/>
                     <a:lstStyle/>
                     <a:p>
-                      <a:pPr indent="0" marL="0">
+                      <a:pPr marL="0" indent="0">
                         <a:buNone/>
                       </a:pPr>
                       <a:r>
@@ -8730,7 +8975,7 @@
                     <a:bodyPr/>
                     <a:lstStyle/>
                     <a:p>
-                      <a:pPr indent="0" marL="0">
+                      <a:pPr marL="0" indent="0">
                         <a:buNone/>
                       </a:pPr>
                       <a:r>
@@ -8790,6 +9035,11 @@
                     </a:lnB>
                   </a:tcPr>
                 </a:tc>
+                <a:extLst>
+                  <a:ext uri="{0D108BD9-81ED-4DB2-BD59-A6C34878D82A}">
+                    <a16:rowId xmlns:a16="http://schemas.microsoft.com/office/drawing/2014/main" val="10004"/>
+                  </a:ext>
+                </a:extLst>
               </a:tr>
               <a:tr h="201168">
                 <a:tc>
@@ -8797,7 +9047,7 @@
                     <a:bodyPr/>
                     <a:lstStyle/>
                     <a:p>
-                      <a:pPr indent="0" marL="0">
+                      <a:pPr marL="0" indent="0">
                         <a:buNone/>
                       </a:pPr>
                       <a:r>
@@ -8862,7 +9112,7 @@
                     <a:bodyPr/>
                     <a:lstStyle/>
                     <a:p>
-                      <a:pPr indent="0" marL="0">
+                      <a:pPr marL="0" indent="0">
                         <a:buNone/>
                       </a:pPr>
                       <a:r>
@@ -8927,7 +9177,7 @@
                     <a:bodyPr/>
                     <a:lstStyle/>
                     <a:p>
-                      <a:pPr indent="0" marL="0">
+                      <a:pPr marL="0" indent="0">
                         <a:buNone/>
                       </a:pPr>
                       <a:r>
@@ -8992,7 +9242,7 @@
                     <a:bodyPr/>
                     <a:lstStyle/>
                     <a:p>
-                      <a:pPr indent="0" marL="0">
+                      <a:pPr marL="0" indent="0">
                         <a:buNone/>
                       </a:pPr>
                       <a:r>
@@ -9057,7 +9307,7 @@
                     <a:bodyPr/>
                     <a:lstStyle/>
                     <a:p>
-                      <a:pPr indent="0" marL="0">
+                      <a:pPr marL="0" indent="0">
                         <a:buNone/>
                       </a:pPr>
                       <a:r>
@@ -9122,7 +9372,7 @@
                     <a:bodyPr/>
                     <a:lstStyle/>
                     <a:p>
-                      <a:pPr indent="0" marL="0">
+                      <a:pPr marL="0" indent="0">
                         <a:buNone/>
                       </a:pPr>
                       <a:r>
@@ -9182,6 +9432,11 @@
                     </a:lnB>
                   </a:tcPr>
                 </a:tc>
+                <a:extLst>
+                  <a:ext uri="{0D108BD9-81ED-4DB2-BD59-A6C34878D82A}">
+                    <a16:rowId xmlns:a16="http://schemas.microsoft.com/office/drawing/2014/main" val="10005"/>
+                  </a:ext>
+                </a:extLst>
               </a:tr>
               <a:tr h="201168">
                 <a:tc>
@@ -9189,7 +9444,7 @@
                     <a:bodyPr/>
                     <a:lstStyle/>
                     <a:p>
-                      <a:pPr indent="0" marL="0">
+                      <a:pPr marL="0" indent="0">
                         <a:buNone/>
                       </a:pPr>
                       <a:r>
@@ -9254,7 +9509,7 @@
                     <a:bodyPr/>
                     <a:lstStyle/>
                     <a:p>
-                      <a:pPr indent="0" marL="0">
+                      <a:pPr marL="0" indent="0">
                         <a:buNone/>
                       </a:pPr>
                       <a:r>
@@ -9319,7 +9574,7 @@
                     <a:bodyPr/>
                     <a:lstStyle/>
                     <a:p>
-                      <a:pPr indent="0" marL="0">
+                      <a:pPr marL="0" indent="0">
                         <a:buNone/>
                       </a:pPr>
                       <a:r>
@@ -9384,7 +9639,7 @@
                     <a:bodyPr/>
                     <a:lstStyle/>
                     <a:p>
-                      <a:pPr indent="0" marL="0">
+                      <a:pPr marL="0" indent="0">
                         <a:buNone/>
                       </a:pPr>
                       <a:r>
@@ -9449,7 +9704,7 @@
                     <a:bodyPr/>
                     <a:lstStyle/>
                     <a:p>
-                      <a:pPr indent="0" marL="0">
+                      <a:pPr marL="0" indent="0">
                         <a:buNone/>
                       </a:pPr>
                       <a:r>
@@ -9514,7 +9769,7 @@
                     <a:bodyPr/>
                     <a:lstStyle/>
                     <a:p>
-                      <a:pPr indent="0" marL="0">
+                      <a:pPr marL="0" indent="0">
                         <a:buNone/>
                       </a:pPr>
                       <a:r>
@@ -9574,6 +9829,11 @@
                     </a:lnB>
                   </a:tcPr>
                 </a:tc>
+                <a:extLst>
+                  <a:ext uri="{0D108BD9-81ED-4DB2-BD59-A6C34878D82A}">
+                    <a16:rowId xmlns:a16="http://schemas.microsoft.com/office/drawing/2014/main" val="10006"/>
+                  </a:ext>
+                </a:extLst>
               </a:tr>
               <a:tr h="201168">
                 <a:tc>
@@ -9581,7 +9841,7 @@
                     <a:bodyPr/>
                     <a:lstStyle/>
                     <a:p>
-                      <a:pPr indent="0" marL="0">
+                      <a:pPr marL="0" indent="0">
                         <a:buNone/>
                       </a:pPr>
                       <a:r>
@@ -9646,7 +9906,7 @@
                     <a:bodyPr/>
                     <a:lstStyle/>
                     <a:p>
-                      <a:pPr indent="0" marL="0">
+                      <a:pPr marL="0" indent="0">
                         <a:buNone/>
                       </a:pPr>
                       <a:r>
@@ -9711,7 +9971,7 @@
                     <a:bodyPr/>
                     <a:lstStyle/>
                     <a:p>
-                      <a:pPr indent="0" marL="0">
+                      <a:pPr marL="0" indent="0">
                         <a:buNone/>
                       </a:pPr>
                       <a:r>
@@ -9776,7 +10036,7 @@
                     <a:bodyPr/>
                     <a:lstStyle/>
                     <a:p>
-                      <a:pPr indent="0" marL="0">
+                      <a:pPr marL="0" indent="0">
                         <a:buNone/>
                       </a:pPr>
                       <a:r>
@@ -9841,7 +10101,7 @@
                     <a:bodyPr/>
                     <a:lstStyle/>
                     <a:p>
-                      <a:pPr indent="0" marL="0">
+                      <a:pPr marL="0" indent="0">
                         <a:buNone/>
                       </a:pPr>
                       <a:r>
@@ -9906,7 +10166,7 @@
                     <a:bodyPr/>
                     <a:lstStyle/>
                     <a:p>
-                      <a:pPr indent="0" marL="0">
+                      <a:pPr marL="0" indent="0">
                         <a:buNone/>
                       </a:pPr>
                       <a:r>
@@ -9966,6 +10226,11 @@
                     </a:lnB>
                   </a:tcPr>
                 </a:tc>
+                <a:extLst>
+                  <a:ext uri="{0D108BD9-81ED-4DB2-BD59-A6C34878D82A}">
+                    <a16:rowId xmlns:a16="http://schemas.microsoft.com/office/drawing/2014/main" val="10007"/>
+                  </a:ext>
+                </a:extLst>
               </a:tr>
               <a:tr h="201168">
                 <a:tc>
@@ -9973,7 +10238,7 @@
                     <a:bodyPr/>
                     <a:lstStyle/>
                     <a:p>
-                      <a:pPr indent="0" marL="0">
+                      <a:pPr marL="0" indent="0">
                         <a:buNone/>
                       </a:pPr>
                       <a:r>
@@ -10038,7 +10303,7 @@
                     <a:bodyPr/>
                     <a:lstStyle/>
                     <a:p>
-                      <a:pPr indent="0" marL="0">
+                      <a:pPr marL="0" indent="0">
                         <a:buNone/>
                       </a:pPr>
                       <a:r>
@@ -10103,7 +10368,7 @@
                     <a:bodyPr/>
                     <a:lstStyle/>
                     <a:p>
-                      <a:pPr indent="0" marL="0">
+                      <a:pPr marL="0" indent="0">
                         <a:buNone/>
                       </a:pPr>
                       <a:r>
@@ -10168,7 +10433,7 @@
                     <a:bodyPr/>
                     <a:lstStyle/>
                     <a:p>
-                      <a:pPr indent="0" marL="0">
+                      <a:pPr marL="0" indent="0">
                         <a:buNone/>
                       </a:pPr>
                       <a:r>
@@ -10233,7 +10498,7 @@
                     <a:bodyPr/>
                     <a:lstStyle/>
                     <a:p>
-                      <a:pPr indent="0" marL="0">
+                      <a:pPr marL="0" indent="0">
                         <a:buNone/>
                       </a:pPr>
                       <a:r>
@@ -10298,7 +10563,7 @@
                     <a:bodyPr/>
                     <a:lstStyle/>
                     <a:p>
-                      <a:pPr indent="0" marL="0">
+                      <a:pPr marL="0" indent="0">
                         <a:buNone/>
                       </a:pPr>
                       <a:r>
@@ -10358,6 +10623,11 @@
                     </a:lnB>
                   </a:tcPr>
                 </a:tc>
+                <a:extLst>
+                  <a:ext uri="{0D108BD9-81ED-4DB2-BD59-A6C34878D82A}">
+                    <a16:rowId xmlns:a16="http://schemas.microsoft.com/office/drawing/2014/main" val="10008"/>
+                  </a:ext>
+                </a:extLst>
               </a:tr>
               <a:tr h="201168">
                 <a:tc>
@@ -10365,7 +10635,7 @@
                     <a:bodyPr/>
                     <a:lstStyle/>
                     <a:p>
-                      <a:pPr indent="0" marL="0">
+                      <a:pPr marL="0" indent="0">
                         <a:buNone/>
                       </a:pPr>
                       <a:r>
@@ -10430,7 +10700,7 @@
                     <a:bodyPr/>
                     <a:lstStyle/>
                     <a:p>
-                      <a:pPr indent="0" marL="0">
+                      <a:pPr marL="0" indent="0">
                         <a:buNone/>
                       </a:pPr>
                       <a:r>
@@ -10495,7 +10765,7 @@
                     <a:bodyPr/>
                     <a:lstStyle/>
                     <a:p>
-                      <a:pPr indent="0" marL="0">
+                      <a:pPr marL="0" indent="0">
                         <a:buNone/>
                       </a:pPr>
                       <a:r>
@@ -10560,7 +10830,7 @@
                     <a:bodyPr/>
                     <a:lstStyle/>
                     <a:p>
-                      <a:pPr indent="0" marL="0">
+                      <a:pPr marL="0" indent="0">
                         <a:buNone/>
                       </a:pPr>
                       <a:r>
@@ -10625,7 +10895,7 @@
                     <a:bodyPr/>
                     <a:lstStyle/>
                     <a:p>
-                      <a:pPr indent="0" marL="0">
+                      <a:pPr marL="0" indent="0">
                         <a:buNone/>
                       </a:pPr>
                       <a:r>
@@ -10690,7 +10960,7 @@
                     <a:bodyPr/>
                     <a:lstStyle/>
                     <a:p>
-                      <a:pPr indent="0" marL="0">
+                      <a:pPr marL="0" indent="0">
                         <a:buNone/>
                       </a:pPr>
                       <a:r>
@@ -10750,6 +11020,11 @@
                     </a:lnB>
                   </a:tcPr>
                 </a:tc>
+                <a:extLst>
+                  <a:ext uri="{0D108BD9-81ED-4DB2-BD59-A6C34878D82A}">
+                    <a16:rowId xmlns:a16="http://schemas.microsoft.com/office/drawing/2014/main" val="10009"/>
+                  </a:ext>
+                </a:extLst>
               </a:tr>
               <a:tr h="201168">
                 <a:tc>
@@ -10757,7 +11032,7 @@
                     <a:bodyPr/>
                     <a:lstStyle/>
                     <a:p>
-                      <a:pPr indent="0" marL="0">
+                      <a:pPr marL="0" indent="0">
                         <a:buNone/>
                       </a:pPr>
                       <a:r>
@@ -10822,7 +11097,7 @@
                     <a:bodyPr/>
                     <a:lstStyle/>
                     <a:p>
-                      <a:pPr indent="0" marL="0">
+                      <a:pPr marL="0" indent="0">
                         <a:buNone/>
                       </a:pPr>
                       <a:r>
@@ -10887,7 +11162,7 @@
                     <a:bodyPr/>
                     <a:lstStyle/>
                     <a:p>
-                      <a:pPr indent="0" marL="0">
+                      <a:pPr marL="0" indent="0">
                         <a:buNone/>
                       </a:pPr>
                       <a:r>
@@ -10952,7 +11227,7 @@
                     <a:bodyPr/>
                     <a:lstStyle/>
                     <a:p>
-                      <a:pPr indent="0" marL="0">
+                      <a:pPr marL="0" indent="0">
                         <a:buNone/>
                       </a:pPr>
                       <a:r>
@@ -11017,7 +11292,7 @@
                     <a:bodyPr/>
                     <a:lstStyle/>
                     <a:p>
-                      <a:pPr indent="0" marL="0">
+                      <a:pPr marL="0" indent="0">
                         <a:buNone/>
                       </a:pPr>
                       <a:r>
@@ -11082,7 +11357,7 @@
                     <a:bodyPr/>
                     <a:lstStyle/>
                     <a:p>
-                      <a:pPr indent="0" marL="0">
+                      <a:pPr marL="0" indent="0">
                         <a:buNone/>
                       </a:pPr>
                       <a:r>
@@ -11142,6 +11417,11 @@
                     </a:lnB>
                   </a:tcPr>
                 </a:tc>
+                <a:extLst>
+                  <a:ext uri="{0D108BD9-81ED-4DB2-BD59-A6C34878D82A}">
+                    <a16:rowId xmlns:a16="http://schemas.microsoft.com/office/drawing/2014/main" val="10010"/>
+                  </a:ext>
+                </a:extLst>
               </a:tr>
               <a:tr h="201168">
                 <a:tc>
@@ -11149,7 +11429,7 @@
                     <a:bodyPr/>
                     <a:lstStyle/>
                     <a:p>
-                      <a:pPr indent="0" marL="0">
+                      <a:pPr marL="0" indent="0">
                         <a:buNone/>
                       </a:pPr>
                       <a:r>
@@ -11214,7 +11494,7 @@
                     <a:bodyPr/>
                     <a:lstStyle/>
                     <a:p>
-                      <a:pPr indent="0" marL="0">
+                      <a:pPr marL="0" indent="0">
                         <a:buNone/>
                       </a:pPr>
                       <a:r>
@@ -11279,7 +11559,7 @@
                     <a:bodyPr/>
                     <a:lstStyle/>
                     <a:p>
-                      <a:pPr indent="0" marL="0">
+                      <a:pPr marL="0" indent="0">
                         <a:buNone/>
                       </a:pPr>
                       <a:r>
@@ -11344,7 +11624,7 @@
                     <a:bodyPr/>
                     <a:lstStyle/>
                     <a:p>
-                      <a:pPr indent="0" marL="0">
+                      <a:pPr marL="0" indent="0">
                         <a:buNone/>
                       </a:pPr>
                       <a:r>
@@ -11409,7 +11689,7 @@
                     <a:bodyPr/>
                     <a:lstStyle/>
                     <a:p>
-                      <a:pPr indent="0" marL="0">
+                      <a:pPr marL="0" indent="0">
                         <a:buNone/>
                       </a:pPr>
                       <a:r>
@@ -11474,7 +11754,7 @@
                     <a:bodyPr/>
                     <a:lstStyle/>
                     <a:p>
-                      <a:pPr indent="0" marL="0">
+                      <a:pPr marL="0" indent="0">
                         <a:buNone/>
                       </a:pPr>
                       <a:r>
@@ -11534,6 +11814,11 @@
                     </a:lnB>
                   </a:tcPr>
                 </a:tc>
+                <a:extLst>
+                  <a:ext uri="{0D108BD9-81ED-4DB2-BD59-A6C34878D82A}">
+                    <a16:rowId xmlns:a16="http://schemas.microsoft.com/office/drawing/2014/main" val="10011"/>
+                  </a:ext>
+                </a:extLst>
               </a:tr>
               <a:tr h="201168">
                 <a:tc>
@@ -11541,7 +11826,7 @@
                     <a:bodyPr/>
                     <a:lstStyle/>
                     <a:p>
-                      <a:pPr indent="0" marL="0">
+                      <a:pPr marL="0" indent="0">
                         <a:buNone/>
                       </a:pPr>
                       <a:r>
@@ -11606,7 +11891,7 @@
                     <a:bodyPr/>
                     <a:lstStyle/>
                     <a:p>
-                      <a:pPr indent="0" marL="0">
+                      <a:pPr marL="0" indent="0">
                         <a:buNone/>
                       </a:pPr>
                       <a:r>
@@ -11671,7 +11956,7 @@
                     <a:bodyPr/>
                     <a:lstStyle/>
                     <a:p>
-                      <a:pPr indent="0" marL="0">
+                      <a:pPr marL="0" indent="0">
                         <a:buNone/>
                       </a:pPr>
                       <a:r>
@@ -11736,7 +12021,7 @@
                     <a:bodyPr/>
                     <a:lstStyle/>
                     <a:p>
-                      <a:pPr indent="0" marL="0">
+                      <a:pPr marL="0" indent="0">
                         <a:buNone/>
                       </a:pPr>
                       <a:r>
@@ -11801,7 +12086,7 @@
                     <a:bodyPr/>
                     <a:lstStyle/>
                     <a:p>
-                      <a:pPr indent="0" marL="0">
+                      <a:pPr marL="0" indent="0">
                         <a:buNone/>
                       </a:pPr>
                       <a:r>
@@ -11866,7 +12151,7 @@
                     <a:bodyPr/>
                     <a:lstStyle/>
                     <a:p>
-                      <a:pPr indent="0" marL="0">
+                      <a:pPr marL="0" indent="0">
                         <a:buNone/>
                       </a:pPr>
                       <a:r>
@@ -11926,6 +12211,11 @@
                     </a:lnB>
                   </a:tcPr>
                 </a:tc>
+                <a:extLst>
+                  <a:ext uri="{0D108BD9-81ED-4DB2-BD59-A6C34878D82A}">
+                    <a16:rowId xmlns:a16="http://schemas.microsoft.com/office/drawing/2014/main" val="10012"/>
+                  </a:ext>
+                </a:extLst>
               </a:tr>
               <a:tr h="201168">
                 <a:tc>
@@ -11933,7 +12223,7 @@
                     <a:bodyPr/>
                     <a:lstStyle/>
                     <a:p>
-                      <a:pPr indent="0" marL="0">
+                      <a:pPr marL="0" indent="0">
                         <a:buNone/>
                       </a:pPr>
                       <a:r>
@@ -11998,7 +12288,7 @@
                     <a:bodyPr/>
                     <a:lstStyle/>
                     <a:p>
-                      <a:pPr indent="0" marL="0">
+                      <a:pPr marL="0" indent="0">
                         <a:buNone/>
                       </a:pPr>
                       <a:r>
@@ -12063,7 +12353,7 @@
                     <a:bodyPr/>
                     <a:lstStyle/>
                     <a:p>
-                      <a:pPr indent="0" marL="0">
+                      <a:pPr marL="0" indent="0">
                         <a:buNone/>
                       </a:pPr>
                       <a:r>
@@ -12128,7 +12418,7 @@
                     <a:bodyPr/>
                     <a:lstStyle/>
                     <a:p>
-                      <a:pPr indent="0" marL="0">
+                      <a:pPr marL="0" indent="0">
                         <a:buNone/>
                       </a:pPr>
                       <a:r>
@@ -12193,7 +12483,7 @@
                     <a:bodyPr/>
                     <a:lstStyle/>
                     <a:p>
-                      <a:pPr indent="0" marL="0">
+                      <a:pPr marL="0" indent="0">
                         <a:buNone/>
                       </a:pPr>
                       <a:r>
@@ -12258,7 +12548,7 @@
                     <a:bodyPr/>
                     <a:lstStyle/>
                     <a:p>
-                      <a:pPr indent="0" marL="0">
+                      <a:pPr marL="0" indent="0">
                         <a:buNone/>
                       </a:pPr>
                       <a:r>
@@ -12318,6 +12608,11 @@
                     </a:lnB>
                   </a:tcPr>
                 </a:tc>
+                <a:extLst>
+                  <a:ext uri="{0D108BD9-81ED-4DB2-BD59-A6C34878D82A}">
+                    <a16:rowId xmlns:a16="http://schemas.microsoft.com/office/drawing/2014/main" val="10013"/>
+                  </a:ext>
+                </a:extLst>
               </a:tr>
               <a:tr h="201168">
                 <a:tc>
@@ -12325,7 +12620,7 @@
                     <a:bodyPr/>
                     <a:lstStyle/>
                     <a:p>
-                      <a:pPr indent="0" marL="0">
+                      <a:pPr marL="0" indent="0">
                         <a:buNone/>
                       </a:pPr>
                       <a:r>
@@ -12390,7 +12685,7 @@
                     <a:bodyPr/>
                     <a:lstStyle/>
                     <a:p>
-                      <a:pPr indent="0" marL="0">
+                      <a:pPr marL="0" indent="0">
                         <a:buNone/>
                       </a:pPr>
                       <a:r>
@@ -12455,7 +12750,7 @@
                     <a:bodyPr/>
                     <a:lstStyle/>
                     <a:p>
-                      <a:pPr indent="0" marL="0">
+                      <a:pPr marL="0" indent="0">
                         <a:buNone/>
                       </a:pPr>
                       <a:r>
@@ -12520,7 +12815,7 @@
                     <a:bodyPr/>
                     <a:lstStyle/>
                     <a:p>
-                      <a:pPr indent="0" marL="0">
+                      <a:pPr marL="0" indent="0">
                         <a:buNone/>
                       </a:pPr>
                       <a:r>
@@ -12585,7 +12880,7 @@
                     <a:bodyPr/>
                     <a:lstStyle/>
                     <a:p>
-                      <a:pPr indent="0" marL="0">
+                      <a:pPr marL="0" indent="0">
                         <a:buNone/>
                       </a:pPr>
                       <a:r>
@@ -12650,7 +12945,7 @@
                     <a:bodyPr/>
                     <a:lstStyle/>
                     <a:p>
-                      <a:pPr indent="0" marL="0">
+                      <a:pPr marL="0" indent="0">
                         <a:buNone/>
                       </a:pPr>
                       <a:r>
@@ -12710,6 +13005,11 @@
                     </a:lnB>
                   </a:tcPr>
                 </a:tc>
+                <a:extLst>
+                  <a:ext uri="{0D108BD9-81ED-4DB2-BD59-A6C34878D82A}">
+                    <a16:rowId xmlns:a16="http://schemas.microsoft.com/office/drawing/2014/main" val="10014"/>
+                  </a:ext>
+                </a:extLst>
               </a:tr>
               <a:tr h="201168">
                 <a:tc>
@@ -12717,7 +13017,7 @@
                     <a:bodyPr/>
                     <a:lstStyle/>
                     <a:p>
-                      <a:pPr indent="0" marL="0">
+                      <a:pPr marL="0" indent="0">
                         <a:buNone/>
                       </a:pPr>
                       <a:r>
@@ -12782,7 +13082,7 @@
                     <a:bodyPr/>
                     <a:lstStyle/>
                     <a:p>
-                      <a:pPr indent="0" marL="0">
+                      <a:pPr marL="0" indent="0">
                         <a:buNone/>
                       </a:pPr>
                       <a:r>
@@ -12847,7 +13147,7 @@
                     <a:bodyPr/>
                     <a:lstStyle/>
                     <a:p>
-                      <a:pPr indent="0" marL="0">
+                      <a:pPr marL="0" indent="0">
                         <a:buNone/>
                       </a:pPr>
                       <a:r>
@@ -12912,7 +13212,7 @@
                     <a:bodyPr/>
                     <a:lstStyle/>
                     <a:p>
-                      <a:pPr indent="0" marL="0">
+                      <a:pPr marL="0" indent="0">
                         <a:buNone/>
                       </a:pPr>
                       <a:r>
@@ -12977,7 +13277,7 @@
                     <a:bodyPr/>
                     <a:lstStyle/>
                     <a:p>
-                      <a:pPr indent="0" marL="0">
+                      <a:pPr marL="0" indent="0">
                         <a:buNone/>
                       </a:pPr>
                       <a:r>
@@ -13042,7 +13342,7 @@
                     <a:bodyPr/>
                     <a:lstStyle/>
                     <a:p>
-                      <a:pPr indent="0" marL="0">
+                      <a:pPr marL="0" indent="0">
                         <a:buNone/>
                       </a:pPr>
                       <a:r>
@@ -13102,6 +13402,11 @@
                     </a:lnB>
                   </a:tcPr>
                 </a:tc>
+                <a:extLst>
+                  <a:ext uri="{0D108BD9-81ED-4DB2-BD59-A6C34878D82A}">
+                    <a16:rowId xmlns:a16="http://schemas.microsoft.com/office/drawing/2014/main" val="10015"/>
+                  </a:ext>
+                </a:extLst>
               </a:tr>
               <a:tr h="201168">
                 <a:tc>
@@ -13109,7 +13414,7 @@
                     <a:bodyPr/>
                     <a:lstStyle/>
                     <a:p>
-                      <a:pPr indent="0" marL="0">
+                      <a:pPr marL="0" indent="0">
                         <a:buNone/>
                       </a:pPr>
                       <a:r>
@@ -13174,7 +13479,7 @@
                     <a:bodyPr/>
                     <a:lstStyle/>
                     <a:p>
-                      <a:pPr indent="0" marL="0">
+                      <a:pPr marL="0" indent="0">
                         <a:buNone/>
                       </a:pPr>
                       <a:r>
@@ -13239,7 +13544,7 @@
                     <a:bodyPr/>
                     <a:lstStyle/>
                     <a:p>
-                      <a:pPr indent="0" marL="0">
+                      <a:pPr marL="0" indent="0">
                         <a:buNone/>
                       </a:pPr>
                       <a:r>
@@ -13304,7 +13609,7 @@
                     <a:bodyPr/>
                     <a:lstStyle/>
                     <a:p>
-                      <a:pPr indent="0" marL="0">
+                      <a:pPr marL="0" indent="0">
                         <a:buNone/>
                       </a:pPr>
                       <a:r>
@@ -13369,7 +13674,7 @@
                     <a:bodyPr/>
                     <a:lstStyle/>
                     <a:p>
-                      <a:pPr indent="0" marL="0">
+                      <a:pPr marL="0" indent="0">
                         <a:buNone/>
                       </a:pPr>
                       <a:r>
@@ -13434,7 +13739,7 @@
                     <a:bodyPr/>
                     <a:lstStyle/>
                     <a:p>
-                      <a:pPr indent="0" marL="0">
+                      <a:pPr marL="0" indent="0">
                         <a:buNone/>
                       </a:pPr>
                       <a:r>
@@ -13494,6 +13799,11 @@
                     </a:lnB>
                   </a:tcPr>
                 </a:tc>
+                <a:extLst>
+                  <a:ext uri="{0D108BD9-81ED-4DB2-BD59-A6C34878D82A}">
+                    <a16:rowId xmlns:a16="http://schemas.microsoft.com/office/drawing/2014/main" val="10016"/>
+                  </a:ext>
+                </a:extLst>
               </a:tr>
               <a:tr h="201168">
                 <a:tc>
@@ -13501,7 +13811,7 @@
                     <a:bodyPr/>
                     <a:lstStyle/>
                     <a:p>
-                      <a:pPr indent="0" marL="0">
+                      <a:pPr marL="0" indent="0">
                         <a:buNone/>
                       </a:pPr>
                       <a:r>
@@ -13566,7 +13876,7 @@
                     <a:bodyPr/>
                     <a:lstStyle/>
                     <a:p>
-                      <a:pPr indent="0" marL="0">
+                      <a:pPr marL="0" indent="0">
                         <a:buNone/>
                       </a:pPr>
                       <a:r>
@@ -13631,7 +13941,7 @@
                     <a:bodyPr/>
                     <a:lstStyle/>
                     <a:p>
-                      <a:pPr indent="0" marL="0">
+                      <a:pPr marL="0" indent="0">
                         <a:buNone/>
                       </a:pPr>
                       <a:r>
@@ -13696,7 +14006,7 @@
                     <a:bodyPr/>
                     <a:lstStyle/>
                     <a:p>
-                      <a:pPr indent="0" marL="0">
+                      <a:pPr marL="0" indent="0">
                         <a:buNone/>
                       </a:pPr>
                       <a:r>
@@ -13761,7 +14071,7 @@
                     <a:bodyPr/>
                     <a:lstStyle/>
                     <a:p>
-                      <a:pPr indent="0" marL="0">
+                      <a:pPr marL="0" indent="0">
                         <a:buNone/>
                       </a:pPr>
                       <a:r>
@@ -13826,7 +14136,7 @@
                     <a:bodyPr/>
                     <a:lstStyle/>
                     <a:p>
-                      <a:pPr indent="0" marL="0">
+                      <a:pPr marL="0" indent="0">
                         <a:buNone/>
                       </a:pPr>
                       <a:r>
@@ -13886,284 +14196,16 @@
                     </a:lnB>
                   </a:tcPr>
                 </a:tc>
+                <a:extLst>
+                  <a:ext uri="{0D108BD9-81ED-4DB2-BD59-A6C34878D82A}">
+                    <a16:rowId xmlns:a16="http://schemas.microsoft.com/office/drawing/2014/main" val="10017"/>
+                  </a:ext>
+                </a:extLst>
               </a:tr>
             </a:tbl>
           </a:graphicData>
         </a:graphic>
       </p:graphicFrame>
-      <p:sp>
-        <p:nvSpPr>
-          <p:cNvPr id="5" name="Text 2"/>
-          <p:cNvSpPr/>
-          <p:nvPr/>
-        </p:nvSpPr>
-        <p:spPr>
-          <a:xfrm>
-            <a:off x="457200" y="4983480"/>
-            <a:ext cx="11247120" cy="274320"/>
-          </a:xfrm>
-          <a:prstGeom prst="rect">
-            <a:avLst/>
-          </a:prstGeom>
-          <a:noFill/>
-          <a:ln/>
-        </p:spPr>
-        <p:txBody>
-          <a:bodyPr wrap="square" lIns="0" tIns="0" rIns="0" bIns="0" rtlCol="0" anchor="ctr"/>
-          <a:lstStyle/>
-          <a:p>
-            <a:pPr indent="0" marL="0">
-              <a:buNone/>
-            </a:pPr>
-            <a:r>
-              <a:rPr lang="en-US" sz="1300" b="1" dirty="0">
-                <a:solidFill>
-                  <a:srgbClr val="1F2A44"/>
-                </a:solidFill>
-                <a:latin typeface="Calibri" pitchFamily="34" charset="0"/>
-                <a:ea typeface="Calibri" pitchFamily="34" charset="-122"/>
-                <a:cs typeface="Calibri" pitchFamily="34" charset="-120"/>
-              </a:rPr>
-              <a:t>Notes on bench testing</a:t>
-            </a:r>
-            <a:endParaRPr lang="en-US" sz="1300" dirty="0"/>
-          </a:p>
-        </p:txBody>
-      </p:sp>
-      <p:sp>
-        <p:nvSpPr>
-          <p:cNvPr id="6" name="Text 3"/>
-          <p:cNvSpPr/>
-          <p:nvPr/>
-        </p:nvSpPr>
-        <p:spPr>
-          <a:xfrm>
-            <a:off x="457200" y="5276088"/>
-            <a:ext cx="11247120" cy="201168"/>
-          </a:xfrm>
-          <a:prstGeom prst="rect">
-            <a:avLst/>
-          </a:prstGeom>
-          <a:noFill/>
-          <a:ln/>
-        </p:spPr>
-        <p:txBody>
-          <a:bodyPr wrap="square" lIns="0" tIns="0" rIns="0" bIns="0" rtlCol="0" anchor="ctr"/>
-          <a:lstStyle/>
-          <a:p>
-            <a:pPr indent="0" marL="0">
-              <a:buNone/>
-            </a:pPr>
-            <a:r>
-              <a:rPr lang="en-US" sz="1000" dirty="0">
-                <a:solidFill>
-                  <a:srgbClr val="1F2937"/>
-                </a:solidFill>
-                <a:latin typeface="Calibri" pitchFamily="34" charset="0"/>
-                <a:ea typeface="Calibri" pitchFamily="34" charset="-122"/>
-                <a:cs typeface="Calibri" pitchFamily="34" charset="-120"/>
-              </a:rPr>
-              <a:t>• Run I2C scanner sketch: 0x48 (ADS1115), 0x68 (DS3231), and 0x76 (MS5837) must all appear.</a:t>
-            </a:r>
-            <a:endParaRPr lang="en-US" sz="1000" dirty="0"/>
-          </a:p>
-        </p:txBody>
-      </p:sp>
-      <p:sp>
-        <p:nvSpPr>
-          <p:cNvPr id="7" name="Text 4"/>
-          <p:cNvSpPr/>
-          <p:nvPr/>
-        </p:nvSpPr>
-        <p:spPr>
-          <a:xfrm>
-            <a:off x="457200" y="5495544"/>
-            <a:ext cx="11247120" cy="201168"/>
-          </a:xfrm>
-          <a:prstGeom prst="rect">
-            <a:avLst/>
-          </a:prstGeom>
-          <a:noFill/>
-          <a:ln/>
-        </p:spPr>
-        <p:txBody>
-          <a:bodyPr wrap="square" lIns="0" tIns="0" rIns="0" bIns="0" rtlCol="0" anchor="ctr"/>
-          <a:lstStyle/>
-          <a:p>
-            <a:pPr indent="0" marL="0">
-              <a:buNone/>
-            </a:pPr>
-            <a:r>
-              <a:rPr lang="en-US" sz="1000" dirty="0">
-                <a:solidFill>
-                  <a:srgbClr val="1F2937"/>
-                </a:solidFill>
-                <a:latin typeface="Calibri" pitchFamily="34" charset="0"/>
-                <a:ea typeface="Calibri" pitchFamily="34" charset="-122"/>
-                <a:cs typeface="Calibri" pitchFamily="34" charset="-120"/>
-              </a:rPr>
-              <a:t>• If only some addresses show, check SDA/SCL jumpers and common ground.</a:t>
-            </a:r>
-            <a:endParaRPr lang="en-US" sz="1000" dirty="0"/>
-          </a:p>
-        </p:txBody>
-      </p:sp>
-      <p:sp>
-        <p:nvSpPr>
-          <p:cNvPr id="8" name="Text 5"/>
-          <p:cNvSpPr/>
-          <p:nvPr/>
-        </p:nvSpPr>
-        <p:spPr>
-          <a:xfrm>
-            <a:off x="457200" y="5715000"/>
-            <a:ext cx="11247120" cy="201168"/>
-          </a:xfrm>
-          <a:prstGeom prst="rect">
-            <a:avLst/>
-          </a:prstGeom>
-          <a:noFill/>
-          <a:ln/>
-        </p:spPr>
-        <p:txBody>
-          <a:bodyPr wrap="square" lIns="0" tIns="0" rIns="0" bIns="0" rtlCol="0" anchor="ctr"/>
-          <a:lstStyle/>
-          <a:p>
-            <a:pPr indent="0" marL="0">
-              <a:buNone/>
-            </a:pPr>
-            <a:r>
-              <a:rPr lang="en-US" sz="1000" dirty="0">
-                <a:solidFill>
-                  <a:srgbClr val="1F2937"/>
-                </a:solidFill>
-                <a:latin typeface="Calibri" pitchFamily="34" charset="0"/>
-                <a:ea typeface="Calibri" pitchFamily="34" charset="-122"/>
-                <a:cs typeface="Calibri" pitchFamily="34" charset="-120"/>
-              </a:rPr>
-              <a:t>• SQ-500 is self-powered: never connect it to a voltage rail.</a:t>
-            </a:r>
-            <a:endParaRPr lang="en-US" sz="1000" dirty="0"/>
-          </a:p>
-        </p:txBody>
-      </p:sp>
-      <p:sp>
-        <p:nvSpPr>
-          <p:cNvPr id="9" name="Text 6"/>
-          <p:cNvSpPr/>
-          <p:nvPr/>
-        </p:nvSpPr>
-        <p:spPr>
-          <a:xfrm>
-            <a:off x="457200" y="5934456"/>
-            <a:ext cx="11247120" cy="201168"/>
-          </a:xfrm>
-          <a:prstGeom prst="rect">
-            <a:avLst/>
-          </a:prstGeom>
-          <a:noFill/>
-          <a:ln/>
-        </p:spPr>
-        <p:txBody>
-          <a:bodyPr wrap="square" lIns="0" tIns="0" rIns="0" bIns="0" rtlCol="0" anchor="ctr"/>
-          <a:lstStyle/>
-          <a:p>
-            <a:pPr indent="0" marL="0">
-              <a:buNone/>
-            </a:pPr>
-            <a:r>
-              <a:rPr lang="en-US" sz="1000" dirty="0">
-                <a:solidFill>
-                  <a:srgbClr val="1F2937"/>
-                </a:solidFill>
-                <a:latin typeface="Calibri" pitchFamily="34" charset="0"/>
-                <a:ea typeface="Calibri" pitchFamily="34" charset="-122"/>
-                <a:cs typeface="Calibri" pitchFamily="34" charset="-120"/>
-              </a:rPr>
-              <a:t>• MS5837 PROM CRC is checked at startup — failure indicates wiring or sealing damage.</a:t>
-            </a:r>
-            <a:endParaRPr lang="en-US" sz="1000" dirty="0"/>
-          </a:p>
-        </p:txBody>
-      </p:sp>
-      <p:sp>
-        <p:nvSpPr>
-          <p:cNvPr id="10" name="Text 7"/>
-          <p:cNvSpPr/>
-          <p:nvPr/>
-        </p:nvSpPr>
-        <p:spPr>
-          <a:xfrm>
-            <a:off x="457200" y="6153912"/>
-            <a:ext cx="11247120" cy="201168"/>
-          </a:xfrm>
-          <a:prstGeom prst="rect">
-            <a:avLst/>
-          </a:prstGeom>
-          <a:noFill/>
-          <a:ln/>
-        </p:spPr>
-        <p:txBody>
-          <a:bodyPr wrap="square" lIns="0" tIns="0" rIns="0" bIns="0" rtlCol="0" anchor="ctr"/>
-          <a:lstStyle/>
-          <a:p>
-            <a:pPr indent="0" marL="0">
-              <a:buNone/>
-            </a:pPr>
-            <a:r>
-              <a:rPr lang="en-US" sz="1000" dirty="0">
-                <a:solidFill>
-                  <a:srgbClr val="1F2937"/>
-                </a:solidFill>
-                <a:latin typeface="Calibri" pitchFamily="34" charset="0"/>
-                <a:ea typeface="Calibri" pitchFamily="34" charset="-122"/>
-                <a:cs typeface="Calibri" pitchFamily="34" charset="-120"/>
-              </a:rPr>
-              <a:t>• Underwater PPFD = air PPFD × 1.25 (immersion correction for SQ-500-SS, S/N ≥ 2876).</a:t>
-            </a:r>
-            <a:endParaRPr lang="en-US" sz="1000" dirty="0"/>
-          </a:p>
-        </p:txBody>
-      </p:sp>
-      <p:sp>
-        <p:nvSpPr>
-          <p:cNvPr id="11" name="Text 8"/>
-          <p:cNvSpPr/>
-          <p:nvPr/>
-        </p:nvSpPr>
-        <p:spPr>
-          <a:xfrm>
-            <a:off x="457200" y="6565392"/>
-            <a:ext cx="11247120" cy="201168"/>
-          </a:xfrm>
-          <a:prstGeom prst="rect">
-            <a:avLst/>
-          </a:prstGeom>
-          <a:noFill/>
-          <a:ln/>
-        </p:spPr>
-        <p:txBody>
-          <a:bodyPr wrap="square" lIns="0" tIns="0" rIns="0" bIns="0" rtlCol="0" anchor="ctr"/>
-          <a:lstStyle/>
-          <a:p>
-            <a:pPr indent="0" marL="0">
-              <a:buNone/>
-            </a:pPr>
-            <a:r>
-              <a:rPr lang="en-US" sz="900" i="1" dirty="0">
-                <a:solidFill>
-                  <a:srgbClr val="6B7280"/>
-                </a:solidFill>
-                <a:latin typeface="Calibri" pitchFamily="34" charset="0"/>
-                <a:ea typeface="Calibri" pitchFamily="34" charset="-122"/>
-                <a:cs typeface="Calibri" pitchFamily="34" charset="-120"/>
-              </a:rPr>
-              <a:t>PARcast — github.com/LoriAzniveBerberian/PARcast</a:t>
-            </a:r>
-            <a:endParaRPr lang="en-US" sz="900" dirty="0"/>
-          </a:p>
-        </p:txBody>
-      </p:sp>
     </p:spTree>
   </p:cSld>
   <p:clrMapOvr>
@@ -14465,4 +14507,319 @@
     </a:ext>
   </a:extLst>
 </a:theme>
+</file>
+
+<file path=ppt/theme/theme2.xml><?xml version="1.0" encoding="utf-8"?>
+<a:theme xmlns:a="http://schemas.openxmlformats.org/drawingml/2006/main" name="Office Theme">
+  <a:themeElements>
+    <a:clrScheme name="Office">
+      <a:dk1>
+        <a:sysClr val="windowText" lastClr="000000"/>
+      </a:dk1>
+      <a:lt1>
+        <a:sysClr val="window" lastClr="FFFFFF"/>
+      </a:lt1>
+      <a:dk2>
+        <a:srgbClr val="0E2841"/>
+      </a:dk2>
+      <a:lt2>
+        <a:srgbClr val="E8E8E8"/>
+      </a:lt2>
+      <a:accent1>
+        <a:srgbClr val="156082"/>
+      </a:accent1>
+      <a:accent2>
+        <a:srgbClr val="E97132"/>
+      </a:accent2>
+      <a:accent3>
+        <a:srgbClr val="196B24"/>
+      </a:accent3>
+      <a:accent4>
+        <a:srgbClr val="0F9ED5"/>
+      </a:accent4>
+      <a:accent5>
+        <a:srgbClr val="A02B93"/>
+      </a:accent5>
+      <a:accent6>
+        <a:srgbClr val="4EA72E"/>
+      </a:accent6>
+      <a:hlink>
+        <a:srgbClr val="467886"/>
+      </a:hlink>
+      <a:folHlink>
+        <a:srgbClr val="96607D"/>
+      </a:folHlink>
+    </a:clrScheme>
+    <a:fontScheme name="Office">
+      <a:majorFont>
+        <a:latin typeface="Aptos Display" panose="02110004020202020204"/>
+        <a:ea typeface=""/>
+        <a:cs typeface=""/>
+        <a:font script="Jpan" typeface="游ゴシック Light"/>
+        <a:font script="Hang" typeface="맑은 고딕"/>
+        <a:font script="Hans" typeface="等线 Light"/>
+        <a:font script="Hant" typeface="新細明體"/>
+        <a:font script="Arab" typeface="Times New Roman"/>
+        <a:font script="Hebr" typeface="Times New Roman"/>
+        <a:font script="Thai" typeface="Angsana New"/>
+        <a:font script="Ethi" typeface="Nyala"/>
+        <a:font script="Beng" typeface="Vrinda"/>
+        <a:font script="Gujr" typeface="Shruti"/>
+        <a:font script="Khmr" typeface="MoolBoran"/>
+        <a:font script="Knda" typeface="Tunga"/>
+        <a:font script="Guru" typeface="Raavi"/>
+        <a:font script="Cans" typeface="Euphemia"/>
+        <a:font script="Cher" typeface="Plantagenet Cherokee"/>
+        <a:font script="Yiii" typeface="Microsoft Yi Baiti"/>
+        <a:font script="Tibt" typeface="Microsoft Himalaya"/>
+        <a:font script="Thaa" typeface="MV Boli"/>
+        <a:font script="Deva" typeface="Mangal"/>
+        <a:font script="Telu" typeface="Gautami"/>
+        <a:font script="Taml" typeface="Latha"/>
+        <a:font script="Syrc" typeface="Estrangelo Edessa"/>
+        <a:font script="Orya" typeface="Kalinga"/>
+        <a:font script="Mlym" typeface="Kartika"/>
+        <a:font script="Laoo" typeface="DokChampa"/>
+        <a:font script="Sinh" typeface="Iskoola Pota"/>
+        <a:font script="Mong" typeface="Mongolian Baiti"/>
+        <a:font script="Viet" typeface="Times New Roman"/>
+        <a:font script="Uigh" typeface="Microsoft Uighur"/>
+        <a:font script="Geor" typeface="Sylfaen"/>
+        <a:font script="Armn" typeface="Arial"/>
+        <a:font script="Bugi" typeface="Leelawadee UI"/>
+        <a:font script="Bopo" typeface="Microsoft JhengHei"/>
+        <a:font script="Java" typeface="Javanese Text"/>
+        <a:font script="Lisu" typeface="Segoe UI"/>
+        <a:font script="Mymr" typeface="Myanmar Text"/>
+        <a:font script="Nkoo" typeface="Ebrima"/>
+        <a:font script="Olck" typeface="Nirmala UI"/>
+        <a:font script="Osma" typeface="Ebrima"/>
+        <a:font script="Phag" typeface="Phagspa"/>
+        <a:font script="Syrn" typeface="Estrangelo Edessa"/>
+        <a:font script="Syrj" typeface="Estrangelo Edessa"/>
+        <a:font script="Syre" typeface="Estrangelo Edessa"/>
+        <a:font script="Sora" typeface="Nirmala UI"/>
+        <a:font script="Tale" typeface="Microsoft Tai Le"/>
+        <a:font script="Talu" typeface="Microsoft New Tai Lue"/>
+        <a:font script="Tfng" typeface="Ebrima"/>
+      </a:majorFont>
+      <a:minorFont>
+        <a:latin typeface="Aptos" panose="02110004020202020204"/>
+        <a:ea typeface=""/>
+        <a:cs typeface=""/>
+        <a:font script="Jpan" typeface="游ゴシック"/>
+        <a:font script="Hang" typeface="맑은 고딕"/>
+        <a:font script="Hans" typeface="等线"/>
+        <a:font script="Hant" typeface="新細明體"/>
+        <a:font script="Arab" typeface="Arial"/>
+        <a:font script="Hebr" typeface="Arial"/>
+        <a:font script="Thai" typeface="Cordia New"/>
+        <a:font script="Ethi" typeface="Nyala"/>
+        <a:font script="Beng" typeface="Vrinda"/>
+        <a:font script="Gujr" typeface="Shruti"/>
+        <a:font script="Khmr" typeface="DaunPenh"/>
+        <a:font script="Knda" typeface="Tunga"/>
+        <a:font script="Guru" typeface="Raavi"/>
+        <a:font script="Cans" typeface="Euphemia"/>
+        <a:font script="Cher" typeface="Plantagenet Cherokee"/>
+        <a:font script="Yiii" typeface="Microsoft Yi Baiti"/>
+        <a:font script="Tibt" typeface="Microsoft Himalaya"/>
+        <a:font script="Thaa" typeface="MV Boli"/>
+        <a:font script="Deva" typeface="Mangal"/>
+        <a:font script="Telu" typeface="Gautami"/>
+        <a:font script="Taml" typeface="Latha"/>
+        <a:font script="Syrc" typeface="Estrangelo Edessa"/>
+        <a:font script="Orya" typeface="Kalinga"/>
+        <a:font script="Mlym" typeface="Kartika"/>
+        <a:font script="Laoo" typeface="DokChampa"/>
+        <a:font script="Sinh" typeface="Iskoola Pota"/>
+        <a:font script="Mong" typeface="Mongolian Baiti"/>
+        <a:font script="Viet" typeface="Arial"/>
+        <a:font script="Uigh" typeface="Microsoft Uighur"/>
+        <a:font script="Geor" typeface="Sylfaen"/>
+        <a:font script="Armn" typeface="Arial"/>
+        <a:font script="Bugi" typeface="Leelawadee UI"/>
+        <a:font script="Bopo" typeface="Microsoft JhengHei"/>
+        <a:font script="Java" typeface="Javanese Text"/>
+        <a:font script="Lisu" typeface="Segoe UI"/>
+        <a:font script="Mymr" typeface="Myanmar Text"/>
+        <a:font script="Nkoo" typeface="Ebrima"/>
+        <a:font script="Olck" typeface="Nirmala UI"/>
+        <a:font script="Osma" typeface="Ebrima"/>
+        <a:font script="Phag" typeface="Phagspa"/>
+        <a:font script="Syrn" typeface="Estrangelo Edessa"/>
+        <a:font script="Syrj" typeface="Estrangelo Edessa"/>
+        <a:font script="Syre" typeface="Estrangelo Edessa"/>
+        <a:font script="Sora" typeface="Nirmala UI"/>
+        <a:font script="Tale" typeface="Microsoft Tai Le"/>
+        <a:font script="Talu" typeface="Microsoft New Tai Lue"/>
+        <a:font script="Tfng" typeface="Ebrima"/>
+      </a:minorFont>
+    </a:fontScheme>
+    <a:fmtScheme name="Office">
+      <a:fillStyleLst>
+        <a:solidFill>
+          <a:schemeClr val="phClr"/>
+        </a:solidFill>
+        <a:gradFill rotWithShape="1">
+          <a:gsLst>
+            <a:gs pos="0">
+              <a:schemeClr val="phClr">
+                <a:lumMod val="110000"/>
+                <a:satMod val="105000"/>
+                <a:tint val="67000"/>
+              </a:schemeClr>
+            </a:gs>
+            <a:gs pos="50000">
+              <a:schemeClr val="phClr">
+                <a:lumMod val="105000"/>
+                <a:satMod val="103000"/>
+                <a:tint val="73000"/>
+              </a:schemeClr>
+            </a:gs>
+            <a:gs pos="100000">
+              <a:schemeClr val="phClr">
+                <a:lumMod val="105000"/>
+                <a:satMod val="109000"/>
+                <a:tint val="81000"/>
+              </a:schemeClr>
+            </a:gs>
+          </a:gsLst>
+          <a:lin ang="5400000" scaled="0"/>
+        </a:gradFill>
+        <a:gradFill rotWithShape="1">
+          <a:gsLst>
+            <a:gs pos="0">
+              <a:schemeClr val="phClr">
+                <a:satMod val="103000"/>
+                <a:lumMod val="102000"/>
+                <a:tint val="94000"/>
+              </a:schemeClr>
+            </a:gs>
+            <a:gs pos="50000">
+              <a:schemeClr val="phClr">
+                <a:satMod val="110000"/>
+                <a:lumMod val="100000"/>
+                <a:shade val="100000"/>
+              </a:schemeClr>
+            </a:gs>
+            <a:gs pos="100000">
+              <a:schemeClr val="phClr">
+                <a:lumMod val="99000"/>
+                <a:satMod val="120000"/>
+                <a:shade val="78000"/>
+              </a:schemeClr>
+            </a:gs>
+          </a:gsLst>
+          <a:lin ang="5400000" scaled="0"/>
+        </a:gradFill>
+      </a:fillStyleLst>
+      <a:lnStyleLst>
+        <a:ln w="12700" cap="flat" cmpd="sng" algn="ctr">
+          <a:solidFill>
+            <a:schemeClr val="phClr"/>
+          </a:solidFill>
+          <a:prstDash val="solid"/>
+          <a:miter lim="800000"/>
+        </a:ln>
+        <a:ln w="19050" cap="flat" cmpd="sng" algn="ctr">
+          <a:solidFill>
+            <a:schemeClr val="phClr"/>
+          </a:solidFill>
+          <a:prstDash val="solid"/>
+          <a:miter lim="800000"/>
+        </a:ln>
+        <a:ln w="25400" cap="flat" cmpd="sng" algn="ctr">
+          <a:solidFill>
+            <a:schemeClr val="phClr"/>
+          </a:solidFill>
+          <a:prstDash val="solid"/>
+          <a:miter lim="800000"/>
+        </a:ln>
+      </a:lnStyleLst>
+      <a:effectStyleLst>
+        <a:effectStyle>
+          <a:effectLst/>
+        </a:effectStyle>
+        <a:effectStyle>
+          <a:effectLst/>
+        </a:effectStyle>
+        <a:effectStyle>
+          <a:effectLst>
+            <a:outerShdw blurRad="57150" dist="19050" dir="5400000" algn="ctr" rotWithShape="0">
+              <a:srgbClr val="000000">
+                <a:alpha val="63000"/>
+              </a:srgbClr>
+            </a:outerShdw>
+          </a:effectLst>
+        </a:effectStyle>
+      </a:effectStyleLst>
+      <a:bgFillStyleLst>
+        <a:solidFill>
+          <a:schemeClr val="phClr"/>
+        </a:solidFill>
+        <a:solidFill>
+          <a:schemeClr val="phClr">
+            <a:tint val="95000"/>
+            <a:satMod val="170000"/>
+          </a:schemeClr>
+        </a:solidFill>
+        <a:gradFill rotWithShape="1">
+          <a:gsLst>
+            <a:gs pos="0">
+              <a:schemeClr val="phClr">
+                <a:tint val="93000"/>
+                <a:satMod val="150000"/>
+                <a:shade val="98000"/>
+                <a:lumMod val="102000"/>
+              </a:schemeClr>
+            </a:gs>
+            <a:gs pos="50000">
+              <a:schemeClr val="phClr">
+                <a:tint val="98000"/>
+                <a:satMod val="130000"/>
+                <a:shade val="90000"/>
+                <a:lumMod val="103000"/>
+              </a:schemeClr>
+            </a:gs>
+            <a:gs pos="100000">
+              <a:schemeClr val="phClr">
+                <a:shade val="63000"/>
+                <a:satMod val="120000"/>
+              </a:schemeClr>
+            </a:gs>
+          </a:gsLst>
+          <a:lin ang="5400000" scaled="0"/>
+        </a:gradFill>
+      </a:bgFillStyleLst>
+    </a:fmtScheme>
+  </a:themeElements>
+  <a:objectDefaults>
+    <a:lnDef>
+      <a:spPr/>
+      <a:bodyPr/>
+      <a:lstStyle/>
+      <a:style>
+        <a:lnRef idx="2">
+          <a:schemeClr val="accent1"/>
+        </a:lnRef>
+        <a:fillRef idx="0">
+          <a:schemeClr val="accent1"/>
+        </a:fillRef>
+        <a:effectRef idx="1">
+          <a:schemeClr val="accent1"/>
+        </a:effectRef>
+        <a:fontRef idx="minor">
+          <a:schemeClr val="tx1"/>
+        </a:fontRef>
+      </a:style>
+    </a:lnDef>
+  </a:objectDefaults>
+  <a:extraClrSchemeLst/>
+  <a:extLst>
+    <a:ext uri="{05A4C25C-085E-4340-85A3-A5531E510DB2}">
+      <thm15:themeFamily xmlns:thm15="http://schemas.microsoft.com/office/thememl/2012/main" name="Office Theme" id="{2E142A2C-CD16-42D6-873A-C26D2A0506FA}" vid="{1BDDFF52-6CD6-40A5-AB3C-68EB2F1E4D0A}"/>
+    </a:ext>
+  </a:extLst>
+</a:theme>
 </file>
</xml_diff>